<commit_message>
docs: add zeroth-review presentation and drop the recap slide from the first review
The zeroth review deck follows the order the department uses: abstract,
problem statement and objective, implementation outline, literature survey,
references. Two new diagrams were drawn for it, kept high level on purpose
since the detailed versions belong in the first review.

The first review no longer opens with a recap of the zeroth review. The
contents slide and the speaker notes were adjusted to match, leaving 20 slides.

Both decks now share their layout. deck_common.py holds the slide furniture
and diagram_style.py holds the colours and type, so the two presentations come
out looking the same and a change to either applies to both.

Both are listed in data.js, so they preview inside the tracker.
</commit_message>
<xml_diff>
--- a/docs/reviews/first-review/Predictive_BMS_First_Review.pptx
+++ b/docs/reviews/first-review/Predictive_BMS_First_Review.pptx
@@ -25,7 +25,6 @@
     <p:sldId id="273" r:id="rId25"/>
     <p:sldId id="274" r:id="rId26"/>
     <p:sldId id="275" r:id="rId27"/>
-    <p:sldId id="276" r:id="rId28"/>
   </p:sldIdLst>
   <p:sldSz cx="12191695" cy="6858000" type="screen4x3"/>
   <p:notesSz cx="6858000" cy="9144000"/>
@@ -612,42 +611,47 @@
           <a:lstStyle/>
           <a:p>
             <a:r>
-              <a:t>On the left is the divider for a cell tap. All four taps use the same ratio, so</a:t>
-            </a:r>
-          </a:p>
-          <a:p>
-            <a:r>
-              <a:t>the top tap sets it: the full pack has to land inside the ADC range, which gives</a:t>
-            </a:r>
-          </a:p>
-          <a:p>
-            <a:r>
-              <a:t>0.128 and about 4.7 millivolts per count once it is referred back to the tap.</a:t>
-            </a:r>
-          </a:p>
-          <a:p>
-            <a:r>
-              <a:t>That is not precise enough for a production BMS, which is why I have noted an</a:t>
-            </a:r>
-          </a:p>
-          <a:p>
-            <a:r>
-              <a:t>external 16-bit converter as the upgrade path. On the right is the thermistor</a:t>
-            </a:r>
-          </a:p>
-          <a:p>
-            <a:r>
-              <a:t>input. The useful thing here is that a fixed calibration error cancels out when</a:t>
-            </a:r>
-          </a:p>
-          <a:p>
-            <a:r>
-              <a:t>you take a derivative, so the rate trip is far less sensitive to ADC error than</a:t>
-            </a:r>
-          </a:p>
-          <a:p>
-            <a:r>
-              <a:t>an absolute reading would be.</a:t>
+              <a:t>The two cut-off MOSFETs are wired source to source. That matters because a</a:t>
+            </a:r>
+          </a:p>
+          <a:p>
+            <a:r>
+              <a:t>single MOSFET has a body diode which would keep conducting in one direction even</a:t>
+            </a:r>
+          </a:p>
+          <a:p>
+            <a:r>
+              <a:t>when the device is off. With two facing opposite ways, each one blocks a</a:t>
+            </a:r>
+          </a:p>
+          <a:p>
+            <a:r>
+              <a:t>different direction, so I can stop charging and discharging separately. I chose</a:t>
+            </a:r>
+          </a:p>
+          <a:p>
+            <a:r>
+              <a:t>the IRLZ44N because it is a logic-level part, so a five volt gate is enough, and</a:t>
+            </a:r>
+          </a:p>
+          <a:p>
+            <a:r>
+              <a:t>its on-resistance is about 22 milliohms, which at ten amps is only a couple of</a:t>
+            </a:r>
+          </a:p>
+          <a:p>
+            <a:r>
+              <a:t>watts. On the right, each cell has its own bleed resistor and switch, and an</a:t>
+            </a:r>
+          </a:p>
+          <a:p>
+            <a:r>
+              <a:t>optocoupler keeps the drive isolated so one ground-referenced pin can switch a</a:t>
+            </a:r>
+          </a:p>
+          <a:p>
+            <a:r>
+              <a:t>cell sitting several volts up.</a:t>
             </a:r>
           </a:p>
         </p:txBody>
@@ -717,47 +721,42 @@
           <a:lstStyle/>
           <a:p>
             <a:r>
-              <a:t>The two cut-off MOSFETs are wired source to source. That matters because a</a:t>
-            </a:r>
-          </a:p>
-          <a:p>
-            <a:r>
-              <a:t>single MOSFET has a body diode which would keep conducting in one direction even</a:t>
-            </a:r>
-          </a:p>
-          <a:p>
-            <a:r>
-              <a:t>when the device is off. With two facing opposite ways, each one blocks a</a:t>
-            </a:r>
-          </a:p>
-          <a:p>
-            <a:r>
-              <a:t>different direction, so I can stop charging and discharging separately. I chose</a:t>
-            </a:r>
-          </a:p>
-          <a:p>
-            <a:r>
-              <a:t>the IRLZ44N because it is a logic-level part, so a five volt gate is enough, and</a:t>
-            </a:r>
-          </a:p>
-          <a:p>
-            <a:r>
-              <a:t>its on-resistance is about 22 milliohms, which at ten amps is only a couple of</a:t>
-            </a:r>
-          </a:p>
-          <a:p>
-            <a:r>
-              <a:t>watts. On the right, each cell has its own bleed resistor and switch, and an</a:t>
-            </a:r>
-          </a:p>
-          <a:p>
-            <a:r>
-              <a:t>optocoupler keeps the drive isolated so one ground-referenced pin can switch a</a:t>
-            </a:r>
-          </a:p>
-          <a:p>
-            <a:r>
-              <a:t>cell sitting several volts up.</a:t>
+              <a:t>The firmware runs three FreeRTOS tasks. The sensor task reads everything at ten</a:t>
+            </a:r>
+          </a:p>
+          <a:p>
+            <a:r>
+              <a:t>hertz and filters it. The safety task owns the state machine and is the only</a:t>
+            </a:r>
+          </a:p>
+          <a:p>
+            <a:r>
+              <a:t>thing allowed to touch the MOSFET pins, so there is no way for the telemetry</a:t>
+            </a:r>
+          </a:p>
+          <a:p>
+            <a:r>
+              <a:t>code to accidentally switch the pack. The telemetry task builds the JSON message</a:t>
+            </a:r>
+          </a:p>
+          <a:p>
+            <a:r>
+              <a:t>once a second. On the right is the state machine. The important part is that</a:t>
+            </a:r>
+          </a:p>
+          <a:p>
+            <a:r>
+              <a:t>leaving the cut-off state needs both a low rate and a low temperature, held for</a:t>
+            </a:r>
+          </a:p>
+          <a:p>
+            <a:r>
+              <a:t>five seconds, and after three trips in ten minutes it latches until someone</a:t>
+            </a:r>
+          </a:p>
+          <a:p>
+            <a:r>
+              <a:t>resets it by hand.</a:t>
             </a:r>
           </a:p>
         </p:txBody>
@@ -827,42 +826,47 @@
           <a:lstStyle/>
           <a:p>
             <a:r>
-              <a:t>The firmware runs three FreeRTOS tasks. The sensor task reads everything at ten</a:t>
-            </a:r>
-          </a:p>
-          <a:p>
-            <a:r>
-              <a:t>hertz and filters it. The safety task owns the state machine and is the only</a:t>
-            </a:r>
-          </a:p>
-          <a:p>
-            <a:r>
-              <a:t>thing allowed to touch the MOSFET pins, so there is no way for the telemetry</a:t>
-            </a:r>
-          </a:p>
-          <a:p>
-            <a:r>
-              <a:t>code to accidentally switch the pack. The telemetry task builds the JSON message</a:t>
-            </a:r>
-          </a:p>
-          <a:p>
-            <a:r>
-              <a:t>once a second. On the right is the state machine. The important part is that</a:t>
-            </a:r>
-          </a:p>
-          <a:p>
-            <a:r>
-              <a:t>leaving the cut-off state needs both a low rate and a low temperature, held for</a:t>
-            </a:r>
-          </a:p>
-          <a:p>
-            <a:r>
-              <a:t>five seconds, and after three trips in ten minutes it latches until someone</a:t>
-            </a:r>
-          </a:p>
-          <a:p>
-            <a:r>
-              <a:t>resets it by hand.</a:t>
+              <a:t>This is the core of the project in ten lines. The order matters. If you take the</a:t>
+            </a:r>
+          </a:p>
+          <a:p>
+            <a:r>
+              <a:t>slope of raw readings you mostly measure noise, because differentiating makes</a:t>
+            </a:r>
+          </a:p>
+          <a:p>
+            <a:r>
+              <a:t>noise worse, so the smoothing has to come first. Then the slope itself gets</a:t>
+            </a:r>
+          </a:p>
+          <a:p>
+            <a:r>
+              <a:t>smoothed again over a one second window. The threshold of one degree per second</a:t>
+            </a:r>
+          </a:p>
+          <a:p>
+            <a:r>
+              <a:t>comes from the Chen paper in my literature survey. The sixty degree line is</a:t>
+            </a:r>
+          </a:p>
+          <a:p>
+            <a:r>
+              <a:t>still there as a backstop, but in a real runaway the rate trip fires well before</a:t>
+            </a:r>
+          </a:p>
+          <a:p>
+            <a:r>
+              <a:t>it. The last point is the one I like most: because a derivative removes any</a:t>
+            </a:r>
+          </a:p>
+          <a:p>
+            <a:r>
+              <a:t>constant offset, a calibration error that would ruin an absolute reading has</a:t>
+            </a:r>
+          </a:p>
+          <a:p>
+            <a:r>
+              <a:t>almost no effect on the rate.</a:t>
             </a:r>
           </a:p>
         </p:txBody>
@@ -932,47 +936,42 @@
           <a:lstStyle/>
           <a:p>
             <a:r>
-              <a:t>This is the core of the project in ten lines. The order matters. If you take the</a:t>
-            </a:r>
-          </a:p>
-          <a:p>
-            <a:r>
-              <a:t>slope of raw readings you mostly measure noise, because differentiating makes</a:t>
-            </a:r>
-          </a:p>
-          <a:p>
-            <a:r>
-              <a:t>noise worse, so the smoothing has to come first. Then the slope itself gets</a:t>
-            </a:r>
-          </a:p>
-          <a:p>
-            <a:r>
-              <a:t>smoothed again over a one second window. The threshold of one degree per second</a:t>
-            </a:r>
-          </a:p>
-          <a:p>
-            <a:r>
-              <a:t>comes from the Chen paper in my literature survey. The sixty degree line is</a:t>
-            </a:r>
-          </a:p>
-          <a:p>
-            <a:r>
-              <a:t>still there as a backstop, but in a real runaway the rate trip fires well before</a:t>
-            </a:r>
-          </a:p>
-          <a:p>
-            <a:r>
-              <a:t>it. The last point is the one I like most: because a derivative removes any</a:t>
-            </a:r>
-          </a:p>
-          <a:p>
-            <a:r>
-              <a:t>constant offset, a calibration error that would ruin an absolute reading has</a:t>
-            </a:r>
-          </a:p>
-          <a:p>
-            <a:r>
-              <a:t>almost no effect on the rate.</a:t>
+              <a:t>This is a simulated curve, not measured data, and the slide says so. The cell</a:t>
+            </a:r>
+          </a:p>
+          <a:p>
+            <a:r>
+              <a:t>warms slowly, then self-heating takes over and the temperature climbs</a:t>
+            </a:r>
+          </a:p>
+          <a:p>
+            <a:r>
+              <a:t>exponentially. The green line is where the rate trip fires: thirty point eight</a:t>
+            </a:r>
+          </a:p>
+          <a:p>
+            <a:r>
+              <a:t>seconds, with the cell still at only thirty-six degrees. The red line is where a</a:t>
+            </a:r>
+          </a:p>
+          <a:p>
+            <a:r>
+              <a:t>fixed sixty degree limit would fire, at forty point four seconds. That is almost</a:t>
+            </a:r>
+          </a:p>
+          <a:p>
+            <a:r>
+              <a:t>ten seconds earlier, and more importantly the pack is twenty-four degrees cooler</a:t>
+            </a:r>
+          </a:p>
+          <a:p>
+            <a:r>
+              <a:t>when the power is removed. I will replace this with real bench data once the</a:t>
+            </a:r>
+          </a:p>
+          <a:p>
+            <a:r>
+              <a:t>prototype is running.</a:t>
             </a:r>
           </a:p>
         </p:txBody>
@@ -1042,42 +1041,32 @@
           <a:lstStyle/>
           <a:p>
             <a:r>
-              <a:t>This is a simulated curve, not measured data, and the slide says so. The cell</a:t>
-            </a:r>
-          </a:p>
-          <a:p>
-            <a:r>
-              <a:t>warms slowly, then self-heating takes over and the temperature climbs</a:t>
-            </a:r>
-          </a:p>
-          <a:p>
-            <a:r>
-              <a:t>exponentially. The green line is where the rate trip fires: thirty point eight</a:t>
-            </a:r>
-          </a:p>
-          <a:p>
-            <a:r>
-              <a:t>seconds, with the cell still at only thirty-six degrees. The red line is where a</a:t>
-            </a:r>
-          </a:p>
-          <a:p>
-            <a:r>
-              <a:t>fixed sixty degree limit would fire, at forty point four seconds. That is almost</a:t>
-            </a:r>
-          </a:p>
-          <a:p>
-            <a:r>
-              <a:t>ten seconds earlier, and more importantly the pack is twenty-four degrees cooler</a:t>
-            </a:r>
-          </a:p>
-          <a:p>
-            <a:r>
-              <a:t>when the power is removed. I will replace this with real bench data once the</a:t>
-            </a:r>
-          </a:p>
-          <a:p>
-            <a:r>
-              <a:t>prototype is running.</a:t>
+              <a:t>The ESP32 joins the local Wi-Fi and serves a small web page itself, so there is</a:t>
+            </a:r>
+          </a:p>
+          <a:p>
+            <a:r>
+              <a:t>no cloud account and no broker to set up. Once a second the telemetry task</a:t>
+            </a:r>
+          </a:p>
+          <a:p>
+            <a:r>
+              <a:t>builds the JSON message you can see at the bottom left, and pushes it over a</a:t>
+            </a:r>
+          </a:p>
+          <a:p>
+            <a:r>
+              <a:t>WebSocket. The browser draws live gauges and a rolling chart from that. The one</a:t>
+            </a:r>
+          </a:p>
+          <a:p>
+            <a:r>
+              <a:t>message going the other way is the command to clear a latched cut-off, and that</a:t>
+            </a:r>
+          </a:p>
+          <a:p>
+            <a:r>
+              <a:t>is deliberately the only thing the dashboard is allowed to do.</a:t>
             </a:r>
           </a:p>
         </p:txBody>
@@ -1147,32 +1136,32 @@
           <a:lstStyle/>
           <a:p>
             <a:r>
-              <a:t>The ESP32 joins the local Wi-Fi and serves a small web page itself, so there is</a:t>
-            </a:r>
-          </a:p>
-          <a:p>
-            <a:r>
-              <a:t>no cloud account and no broker to set up. Once a second the telemetry task</a:t>
-            </a:r>
-          </a:p>
-          <a:p>
-            <a:r>
-              <a:t>builds the JSON message you can see at the bottom left, and pushes it over a</a:t>
-            </a:r>
-          </a:p>
-          <a:p>
-            <a:r>
-              <a:t>WebSocket. The browser draws live gauges and a rolling chart from that. The one</a:t>
-            </a:r>
-          </a:p>
-          <a:p>
-            <a:r>
-              <a:t>message going the other way is the command to clear a latched cut-off, and that</a:t>
-            </a:r>
-          </a:p>
-          <a:p>
-            <a:r>
-              <a:t>is deliberately the only thing the dashboard is allowed to do.</a:t>
+              <a:t>This is the full parts list. It comes to about three thousand rupees, which is</a:t>
+            </a:r>
+          </a:p>
+          <a:p>
+            <a:r>
+              <a:t>within what I can fund myself. The thermistor price is the only one I have</a:t>
+            </a:r>
+          </a:p>
+          <a:p>
+            <a:r>
+              <a:t>confirmed on a live product page; the rest are the usual retail figures and I</a:t>
+            </a:r>
+          </a:p>
+          <a:p>
+            <a:r>
+              <a:t>have marked them as approximate. The cells are the biggest single line, and I</a:t>
+            </a:r>
+          </a:p>
+          <a:p>
+            <a:r>
+              <a:t>plan to buy them from a seller who will supply matched capacities, because</a:t>
+            </a:r>
+          </a:p>
+          <a:p>
+            <a:r>
+              <a:t>mismatched cells would make the balancing work much harder later.</a:t>
             </a:r>
           </a:p>
         </p:txBody>
@@ -1242,32 +1231,32 @@
           <a:lstStyle/>
           <a:p>
             <a:r>
-              <a:t>This is the full parts list. It comes to about three thousand rupees, which is</a:t>
-            </a:r>
-          </a:p>
-          <a:p>
-            <a:r>
-              <a:t>within what I can fund myself. The thermistor price is the only one I have</a:t>
-            </a:r>
-          </a:p>
-          <a:p>
-            <a:r>
-              <a:t>confirmed on a live product page; the rest are the usual retail figures and I</a:t>
-            </a:r>
-          </a:p>
-          <a:p>
-            <a:r>
-              <a:t>have marked them as approximate. The cells are the biggest single line, and I</a:t>
-            </a:r>
-          </a:p>
-          <a:p>
-            <a:r>
-              <a:t>plan to buy them from a seller who will supply matched capacities, because</a:t>
-            </a:r>
-          </a:p>
-          <a:p>
-            <a:r>
-              <a:t>mismatched cells would make the balancing work much harder later.</a:t>
+              <a:t>This is where I actually am. The approvals phase is finished. Procurement is the</a:t>
+            </a:r>
+          </a:p>
+          <a:p>
+            <a:r>
+              <a:t>live one: the parts list is final and priced, and I am placing the order this</a:t>
+            </a:r>
+          </a:p>
+          <a:p>
+            <a:r>
+              <a:t>week. Nothing on the bench has been built yet, which is honest, but the design</a:t>
+            </a:r>
+          </a:p>
+          <a:p>
+            <a:r>
+              <a:t>work for the later phases is not zero either. The algorithm and the state</a:t>
+            </a:r>
+          </a:p>
+          <a:p>
+            <a:r>
+              <a:t>machine are worked out on paper, and the telemetry message format is decided, so</a:t>
+            </a:r>
+          </a:p>
+          <a:p>
+            <a:r>
+              <a:t>those phases should move quickly once the hardware exists.</a:t>
             </a:r>
           </a:p>
         </p:txBody>
@@ -1337,32 +1326,37 @@
           <a:lstStyle/>
           <a:p>
             <a:r>
-              <a:t>This is where I actually am. The approvals phase is finished. Procurement is the</a:t>
-            </a:r>
-          </a:p>
-          <a:p>
-            <a:r>
-              <a:t>live one: the parts list is final and priced, and I am placing the order this</a:t>
-            </a:r>
-          </a:p>
-          <a:p>
-            <a:r>
-              <a:t>week. Nothing on the bench has been built yet, which is honest, but the design</a:t>
-            </a:r>
-          </a:p>
-          <a:p>
-            <a:r>
-              <a:t>work for the later phases is not zero either. The algorithm and the state</a:t>
-            </a:r>
-          </a:p>
-          <a:p>
-            <a:r>
-              <a:t>machine are worked out on paper, and the telemetry message format is decided, so</a:t>
-            </a:r>
-          </a:p>
-          <a:p>
-            <a:r>
-              <a:t>those phases should move quickly once the hardware exists.</a:t>
+              <a:t>This is the plan for the rest of the semester, twelve weeks from the end of</a:t>
+            </a:r>
+          </a:p>
+          <a:p>
+            <a:r>
+              <a:t>August. Procurement takes two weeks. Prototyping overlaps with it slightly</a:t>
+            </a:r>
+          </a:p>
+          <a:p>
+            <a:r>
+              <a:t>because I can start the sensing board before the cells arrive. The software</a:t>
+            </a:r>
+          </a:p>
+          <a:p>
+            <a:r>
+              <a:t>phase is the longest at four and a half weeks, and it deliberately overlaps</a:t>
+            </a:r>
+          </a:p>
+          <a:p>
+            <a:r>
+              <a:t>prototyping, since I can test the reading and filtering code on the bench supply</a:t>
+            </a:r>
+          </a:p>
+          <a:p>
+            <a:r>
+              <a:t>before the pack is finished. The four dashed lines are the checkpoints I am</a:t>
+            </a:r>
+          </a:p>
+          <a:p>
+            <a:r>
+              <a:t>holding myself to.</a:t>
             </a:r>
           </a:p>
         </p:txBody>
@@ -1432,37 +1426,27 @@
           <a:lstStyle/>
           <a:p>
             <a:r>
-              <a:t>This is the plan for the rest of the semester, twelve weeks from the end of</a:t>
-            </a:r>
-          </a:p>
-          <a:p>
-            <a:r>
-              <a:t>August. Procurement takes two weeks. Prototyping overlaps with it slightly</a:t>
-            </a:r>
-          </a:p>
-          <a:p>
-            <a:r>
-              <a:t>because I can start the sensing board before the cells arrive. The software</a:t>
-            </a:r>
-          </a:p>
-          <a:p>
-            <a:r>
-              <a:t>phase is the longest at four and a half weeks, and it deliberately overlaps</a:t>
-            </a:r>
-          </a:p>
-          <a:p>
-            <a:r>
-              <a:t>prototyping, since I can test the reading and filtering code on the bench supply</a:t>
-            </a:r>
-          </a:p>
-          <a:p>
-            <a:r>
-              <a:t>before the pack is finished. The four dashed lines are the checkpoints I am</a:t>
-            </a:r>
-          </a:p>
-          <a:p>
-            <a:r>
-              <a:t>holding myself to.</a:t>
+              <a:t>These are the four things I expect to be able to show at the end. The second one</a:t>
+            </a:r>
+          </a:p>
+          <a:p>
+            <a:r>
+              <a:t>is the real test of the project, and I plan to prove it by warming a cell with a</a:t>
+            </a:r>
+          </a:p>
+          <a:p>
+            <a:r>
+              <a:t>small heater and recording when each trip fires. The last point matters for a</a:t>
+            </a:r>
+          </a:p>
+          <a:p>
+            <a:r>
+              <a:t>college project: everything on the list can be bought locally, so the work can</a:t>
+            </a:r>
+          </a:p>
+          <a:p>
+            <a:r>
+              <a:t>actually be repeated by someone else in the department.</a:t>
             </a:r>
           </a:p>
         </p:txBody>
@@ -1532,27 +1516,22 @@
           <a:lstStyle/>
           <a:p>
             <a:r>
-              <a:t>These are the four things I expect to be able to show at the end. The second one</a:t>
-            </a:r>
-          </a:p>
-          <a:p>
-            <a:r>
-              <a:t>is the real test of the project, and I plan to prove it by warming a cell with a</a:t>
-            </a:r>
-          </a:p>
-          <a:p>
-            <a:r>
-              <a:t>small heater and recording when each trip fires. The last point matters for a</a:t>
-            </a:r>
-          </a:p>
-          <a:p>
-            <a:r>
-              <a:t>college project: everything on the list can be bought locally, so the work can</a:t>
-            </a:r>
-          </a:p>
-          <a:p>
-            <a:r>
-              <a:t>actually be repeated by someone else in the department.</a:t>
+              <a:t>These are the five sources I have used. The first four are the papers in my</a:t>
+            </a:r>
+          </a:p>
+          <a:p>
+            <a:r>
+              <a:t>literature survey table, numbered in the same order. The last one is the Indian</a:t>
+            </a:r>
+          </a:p>
+          <a:p>
+            <a:r>
+              <a:t>standard that covers sealed lithium cells, and it is the standard whose abuse</a:t>
+            </a:r>
+          </a:p>
+          <a:p>
+            <a:r>
+              <a:t>tests my design is aimed at, although I am not claiming any certification.</a:t>
             </a:r>
           </a:p>
         </p:txBody>
@@ -1622,27 +1601,27 @@
           <a:lstStyle/>
           <a:p>
             <a:r>
-              <a:t>This is the order I will follow. I will start with what was approved in the</a:t>
-            </a:r>
-          </a:p>
-          <a:p>
-            <a:r>
-              <a:t>zeroth review, then explain the problem I am solving and why the usual approach</a:t>
-            </a:r>
-          </a:p>
-          <a:p>
-            <a:r>
-              <a:t>falls short. After that I will go through the circuit design in detail, then the</a:t>
-            </a:r>
-          </a:p>
-          <a:p>
-            <a:r>
-              <a:t>firmware and the algorithm that does the prediction. I will finish with the</a:t>
-            </a:r>
-          </a:p>
-          <a:p>
-            <a:r>
-              <a:t>cost, what I have finished so far, and the plan for the rest of the semester.</a:t>
+              <a:t>This is the order I will follow. I will start with the problem I am solving and</a:t>
+            </a:r>
+          </a:p>
+          <a:p>
+            <a:r>
+              <a:t>why the usual approach falls short. After that I will go through the circuit</a:t>
+            </a:r>
+          </a:p>
+          <a:p>
+            <a:r>
+              <a:t>design in detail, then the firmware and the algorithm that does the prediction.</a:t>
+            </a:r>
+          </a:p>
+          <a:p>
+            <a:r>
+              <a:t>I will finish with the cost, what I have finished so far, and the plan for the</a:t>
+            </a:r>
+          </a:p>
+          <a:p>
+            <a:r>
+              <a:t>rest of the semester.</a:t>
             </a:r>
           </a:p>
         </p:txBody>
@@ -1712,91 +1691,6 @@
           <a:lstStyle/>
           <a:p>
             <a:r>
-              <a:t>These are the five sources I have used. The first four are the papers in my</a:t>
-            </a:r>
-          </a:p>
-          <a:p>
-            <a:r>
-              <a:t>literature survey table, numbered in the same order. The last one is the Indian</a:t>
-            </a:r>
-          </a:p>
-          <a:p>
-            <a:r>
-              <a:t>standard that covers sealed lithium cells, and it is the standard whose abuse</a:t>
-            </a:r>
-          </a:p>
-          <a:p>
-            <a:r>
-              <a:t>tests my design is aimed at, although I am not claiming any certification.</a:t>
-            </a:r>
-          </a:p>
-        </p:txBody>
-      </p:sp>
-      <p:sp>
-        <p:nvSpPr>
-          <p:cNvPr id="4" name="Slide Number Placeholder 3"/>
-          <p:cNvSpPr>
-            <a:spLocks noGrp="1"/>
-          </p:cNvSpPr>
-          <p:nvPr>
-            <p:ph type="sldNum" idx="5" sz="quarter"/>
-          </p:nvPr>
-        </p:nvSpPr>
-        <p:spPr/>
-      </p:sp>
-    </p:spTree>
-  </p:cSld>
-  <p:clrMapOvr>
-    <a:masterClrMapping/>
-  </p:clrMapOvr>
-</p:notes>
-</file>
-
-<file path=ppt/notesSlides/notesSlide21.xml><?xml version="1.0" encoding="utf-8"?>
-<p:notes xmlns:a="http://schemas.openxmlformats.org/drawingml/2006/main" xmlns:p="http://schemas.openxmlformats.org/presentationml/2006/main" xmlns:r="http://schemas.openxmlformats.org/officeDocument/2006/relationships">
-  <p:cSld>
-    <p:spTree>
-      <p:nvGrpSpPr>
-        <p:cNvPr id="1" name=""/>
-        <p:cNvGrpSpPr/>
-        <p:nvPr/>
-      </p:nvGrpSpPr>
-      <p:grpSpPr>
-        <a:xfrm>
-          <a:off x="0" y="0"/>
-          <a:ext cx="0" cy="0"/>
-          <a:chOff x="0" y="0"/>
-          <a:chExt cx="0" cy="0"/>
-        </a:xfrm>
-      </p:grpSpPr>
-      <p:sp>
-        <p:nvSpPr>
-          <p:cNvPr id="2" name="Slide Image Placeholder 1"/>
-          <p:cNvSpPr>
-            <a:spLocks noGrp="1"/>
-          </p:cNvSpPr>
-          <p:nvPr>
-            <p:ph type="sldImg" idx="2"/>
-          </p:nvPr>
-        </p:nvSpPr>
-        <p:spPr/>
-      </p:sp>
-      <p:sp>
-        <p:nvSpPr>
-          <p:cNvPr id="3" name="Notes Placeholder 2"/>
-          <p:cNvSpPr>
-            <a:spLocks noGrp="1"/>
-          </p:cNvSpPr>
-          <p:nvPr>
-            <p:ph type="body" idx="3" sz="quarter"/>
-          </p:nvPr>
-        </p:nvSpPr>
-        <p:spPr/>
-        <p:txBody>
-          <a:bodyPr/>
-          <a:lstStyle/>
-          <a:p>
-            <a:r>
               <a:t>That is the end of my presentation. Thank you for listening. I am happy to take</a:t>
             </a:r>
           </a:p>
@@ -1872,27 +1766,37 @@
           <a:lstStyle/>
           <a:p>
             <a:r>
-              <a:t>In the zeroth review I presented the idea and a block diagram, and the panel</a:t>
-            </a:r>
-          </a:p>
-          <a:p>
-            <a:r>
-              <a:t>approved it. My guide signed off after that, so the approvals phase is finished.</a:t>
-            </a:r>
-          </a:p>
-          <a:p>
-            <a:r>
-              <a:t>Since then I have done the detailed work: I picked real component values,</a:t>
-            </a:r>
-          </a:p>
-          <a:p>
-            <a:r>
-              <a:t>worked out what the ADC can actually resolve, and priced the full parts list.</a:t>
-            </a:r>
-          </a:p>
-          <a:p>
-            <a:r>
-              <a:t>Today I want to show that detail and get feedback before I start building.</a:t>
+              <a:t>This is the gap I am working on. Almost every small battery protection board</a:t>
+            </a:r>
+          </a:p>
+          <a:p>
+            <a:r>
+              <a:t>uses one rule: if the temperature goes above a set value, disconnect. The</a:t>
+            </a:r>
+          </a:p>
+          <a:p>
+            <a:r>
+              <a:t>problem is that the set value tells you nothing until it is reached. A cell that</a:t>
+            </a:r>
+          </a:p>
+          <a:p>
+            <a:r>
+              <a:t>is heating one degree every second is clearly in trouble even when it is only at</a:t>
+            </a:r>
+          </a:p>
+          <a:p>
+            <a:r>
+              <a:t>thirty-five degrees, but a fixed limit ignores that completely. On top of that,</a:t>
+            </a:r>
+          </a:p>
+          <a:p>
+            <a:r>
+              <a:t>the thermistor sits on the outside of the can, so the inside is always hotter</a:t>
+            </a:r>
+          </a:p>
+          <a:p>
+            <a:r>
+              <a:t>than what I measure. Waiting for an absolute number means acting late.</a:t>
             </a:r>
           </a:p>
         </p:txBody>
@@ -1962,37 +1866,27 @@
           <a:lstStyle/>
           <a:p>
             <a:r>
-              <a:t>This is the gap I am working on. Almost every small battery protection board</a:t>
-            </a:r>
-          </a:p>
-          <a:p>
-            <a:r>
-              <a:t>uses one rule: if the temperature goes above a set value, disconnect. The</a:t>
-            </a:r>
-          </a:p>
-          <a:p>
-            <a:r>
-              <a:t>problem is that the set value tells you nothing until it is reached. A cell that</a:t>
-            </a:r>
-          </a:p>
-          <a:p>
-            <a:r>
-              <a:t>is heating one degree every second is clearly in trouble even when it is only at</a:t>
-            </a:r>
-          </a:p>
-          <a:p>
-            <a:r>
-              <a:t>thirty-five degrees, but a fixed limit ignores that completely. On top of that,</a:t>
-            </a:r>
-          </a:p>
-          <a:p>
-            <a:r>
-              <a:t>the thermistor sits on the outside of the can, so the inside is always hotter</a:t>
-            </a:r>
-          </a:p>
-          <a:p>
-            <a:r>
-              <a:t>than what I measure. Waiting for an absolute number means acting late.</a:t>
+              <a:t>These are the five things I want to have working by the end of the project. The</a:t>
+            </a:r>
+          </a:p>
+          <a:p>
+            <a:r>
+              <a:t>third one is the new part and the reason for the project. The fourth matters</a:t>
+            </a:r>
+          </a:p>
+          <a:p>
+            <a:r>
+              <a:t>because a pack that is too cold to charge is still perfectly safe to discharge,</a:t>
+            </a:r>
+          </a:p>
+          <a:p>
+            <a:r>
+              <a:t>so cutting both directions together would be crude. The last one is what makes</a:t>
+            </a:r>
+          </a:p>
+          <a:p>
+            <a:r>
+              <a:t>it possible to actually see what the board is doing while it runs.</a:t>
             </a:r>
           </a:p>
         </p:txBody>
@@ -2062,27 +1956,37 @@
           <a:lstStyle/>
           <a:p>
             <a:r>
-              <a:t>These are the five things I want to have working by the end of the project. The</a:t>
-            </a:r>
-          </a:p>
-          <a:p>
-            <a:r>
-              <a:t>third one is the new part and the reason for the project. The fourth matters</a:t>
-            </a:r>
-          </a:p>
-          <a:p>
-            <a:r>
-              <a:t>because a pack that is too cold to charge is still perfectly safe to discharge,</a:t>
-            </a:r>
-          </a:p>
-          <a:p>
-            <a:r>
-              <a:t>so cutting both directions together would be crude. The last one is what makes</a:t>
-            </a:r>
-          </a:p>
-          <a:p>
-            <a:r>
-              <a:t>it possible to actually see what the board is doing while it runs.</a:t>
+              <a:t>These four papers frame the work. Feng and his co-authors explain what actually</a:t>
+            </a:r>
+          </a:p>
+          <a:p>
+            <a:r>
+              <a:t>happens inside a cell as it runs away, and that is where the physics comes from.</a:t>
+            </a:r>
+          </a:p>
+          <a:p>
+            <a:r>
+              <a:t>Zhang's review shows that most early-warning work needs extra hardware or a</a:t>
+            </a:r>
+          </a:p>
+          <a:p>
+            <a:r>
+              <a:t>server behind it, which a student project cannot use. The Chen paper is the</a:t>
+            </a:r>
+          </a:p>
+          <a:p>
+            <a:r>
+              <a:t>closest to what I am doing, and it is where my one degree per second threshold</a:t>
+            </a:r>
+          </a:p>
+          <a:p>
+            <a:r>
+              <a:t>comes from. Habib's review lists thermal runaway as an open problem but does not</a:t>
+            </a:r>
+          </a:p>
+          <a:p>
+            <a:r>
+              <a:t>build anything, and that is the gap I am filling.</a:t>
             </a:r>
           </a:p>
         </p:txBody>
@@ -2152,37 +2056,32 @@
           <a:lstStyle/>
           <a:p>
             <a:r>
-              <a:t>These four papers frame the work. Feng and his co-authors explain what actually</a:t>
-            </a:r>
-          </a:p>
-          <a:p>
-            <a:r>
-              <a:t>happens inside a cell as it runs away, and that is where the physics comes from.</a:t>
-            </a:r>
-          </a:p>
-          <a:p>
-            <a:r>
-              <a:t>Zhang's review shows that most early-warning work needs extra hardware or a</a:t>
-            </a:r>
-          </a:p>
-          <a:p>
-            <a:r>
-              <a:t>server behind it, which a student project cannot use. The Chen paper is the</a:t>
-            </a:r>
-          </a:p>
-          <a:p>
-            <a:r>
-              <a:t>closest to what I am doing, and it is where my one degree per second threshold</a:t>
-            </a:r>
-          </a:p>
-          <a:p>
-            <a:r>
-              <a:t>comes from. Habib's review lists thermal runaway as an open problem but does not</a:t>
-            </a:r>
-          </a:p>
-          <a:p>
-            <a:r>
-              <a:t>build anything, and that is the gap I am filling.</a:t>
+              <a:t>This is the whole system on one page. The pack feeds the sensing front end,</a:t>
+            </a:r>
+          </a:p>
+          <a:p>
+            <a:r>
+              <a:t>which reports voltage, current and temperature to the ESP32. The ESP32 runs the</a:t>
+            </a:r>
+          </a:p>
+          <a:p>
+            <a:r>
+              <a:t>maths and drives two MOSFETs that sit in the pack's negative return. The same</a:t>
+            </a:r>
+          </a:p>
+          <a:p>
+            <a:r>
+              <a:t>readings go out over Wi-Fi to a dashboard. The one thing worth pointing out is</a:t>
+            </a:r>
+          </a:p>
+          <a:p>
+            <a:r>
+              <a:t>the note at the bottom: the ESP32's second ADC block cannot be used while Wi-Fi</a:t>
+            </a:r>
+          </a:p>
+          <a:p>
+            <a:r>
+              <a:t>is running, so every analogue input has to go to the first block.</a:t>
             </a:r>
           </a:p>
         </p:txBody>
@@ -2252,32 +2151,32 @@
           <a:lstStyle/>
           <a:p>
             <a:r>
-              <a:t>This is the whole system on one page. The pack feeds the sensing front end,</a:t>
-            </a:r>
-          </a:p>
-          <a:p>
-            <a:r>
-              <a:t>which reports voltage, current and temperature to the ESP32. The ESP32 runs the</a:t>
-            </a:r>
-          </a:p>
-          <a:p>
-            <a:r>
-              <a:t>maths and drives two MOSFETs that sit in the pack's negative return. The same</a:t>
-            </a:r>
-          </a:p>
-          <a:p>
-            <a:r>
-              <a:t>readings go out over Wi-Fi to a dashboard. The one thing worth pointing out is</a:t>
-            </a:r>
-          </a:p>
-          <a:p>
-            <a:r>
-              <a:t>the note at the bottom: the ESP32's second ADC block cannot be used while Wi-Fi</a:t>
-            </a:r>
-          </a:p>
-          <a:p>
-            <a:r>
-              <a:t>is running, so every analogue input has to go to the first block.</a:t>
+              <a:t>This is the same system with the real parts in it. Four cell taps go through</a:t>
+            </a:r>
+          </a:p>
+          <a:p>
+            <a:r>
+              <a:t>dividers into the first ADC block. Four thermistors go through a CD4051 analogue</a:t>
+            </a:r>
+          </a:p>
+          <a:p>
+            <a:r>
+              <a:t>multiplexer, because a DevKit board only exposes six usable ADC1 pins and I need</a:t>
+            </a:r>
+          </a:p>
+          <a:p>
+            <a:r>
+              <a:t>eight channels. Current is measured by an INA226 over I2C, which costs no ADC</a:t>
+            </a:r>
+          </a:p>
+          <a:p>
+            <a:r>
+              <a:t>pin at all. A buck module makes the 3.3 volt rail, not a linear regulator,</a:t>
+            </a:r>
+          </a:p>
+          <a:p>
+            <a:r>
+              <a:t>because dropping thirteen volts in a linear part would waste about two watts.</a:t>
             </a:r>
           </a:p>
         </p:txBody>
@@ -2347,32 +2246,32 @@
           <a:lstStyle/>
           <a:p>
             <a:r>
-              <a:t>This is the same system with the real parts in it. Four cell taps go through</a:t>
-            </a:r>
-          </a:p>
-          <a:p>
-            <a:r>
-              <a:t>dividers into the first ADC block. Four thermistors go through a CD4051 analogue</a:t>
-            </a:r>
-          </a:p>
-          <a:p>
-            <a:r>
-              <a:t>multiplexer, because a DevKit board only exposes six usable ADC1 pins and I need</a:t>
-            </a:r>
-          </a:p>
-          <a:p>
-            <a:r>
-              <a:t>eight channels. Current is measured by an INA226 over I2C, which costs no ADC</a:t>
-            </a:r>
-          </a:p>
-          <a:p>
-            <a:r>
-              <a:t>pin at all. A buck module makes the 3.3 volt rail, not a linear regulator,</a:t>
-            </a:r>
-          </a:p>
-          <a:p>
-            <a:r>
-              <a:t>because dropping thirteen volts in a linear part would waste about two watts.</a:t>
+              <a:t>This is the power path on its own. The fuse sits in the positive line as the</a:t>
+            </a:r>
+          </a:p>
+          <a:p>
+            <a:r>
+              <a:t>last-resort protection if the electronics fail completely. Both MOSFETs sit in</a:t>
+            </a:r>
+          </a:p>
+          <a:p>
+            <a:r>
+              <a:t>the negative return, which is the same arrangement commercial protection boards</a:t>
+            </a:r>
+          </a:p>
+          <a:p>
+            <a:r>
+              <a:t>use, because it lets both gates be driven against system ground with no charge</a:t>
+            </a:r>
+          </a:p>
+          <a:p>
+            <a:r>
+              <a:t>pump. The circles are the measurement points: cell voltages at the taps, pack</a:t>
+            </a:r>
+          </a:p>
+          <a:p>
+            <a:r>
+              <a:t>current across the shunt, and temperature at the cells themselves.</a:t>
             </a:r>
           </a:p>
         </p:txBody>
@@ -2442,32 +2341,42 @@
           <a:lstStyle/>
           <a:p>
             <a:r>
-              <a:t>This is the power path on its own. The fuse sits in the positive line as the</a:t>
-            </a:r>
-          </a:p>
-          <a:p>
-            <a:r>
-              <a:t>last-resort protection if the electronics fail completely. Both MOSFETs sit in</a:t>
-            </a:r>
-          </a:p>
-          <a:p>
-            <a:r>
-              <a:t>the negative return, which is the same arrangement commercial protection boards</a:t>
-            </a:r>
-          </a:p>
-          <a:p>
-            <a:r>
-              <a:t>use, because it lets both gates be driven against system ground with no charge</a:t>
-            </a:r>
-          </a:p>
-          <a:p>
-            <a:r>
-              <a:t>pump. The circles are the measurement points: cell voltages at the taps, pack</a:t>
-            </a:r>
-          </a:p>
-          <a:p>
-            <a:r>
-              <a:t>current across the shunt, and temperature at the cells themselves.</a:t>
+              <a:t>On the left is the divider for a cell tap. All four taps use the same ratio, so</a:t>
+            </a:r>
+          </a:p>
+          <a:p>
+            <a:r>
+              <a:t>the top tap sets it: the full pack has to land inside the ADC range, which gives</a:t>
+            </a:r>
+          </a:p>
+          <a:p>
+            <a:r>
+              <a:t>0.128 and about 4.7 millivolts per count once it is referred back to the tap.</a:t>
+            </a:r>
+          </a:p>
+          <a:p>
+            <a:r>
+              <a:t>That is not precise enough for a production BMS, which is why I have noted an</a:t>
+            </a:r>
+          </a:p>
+          <a:p>
+            <a:r>
+              <a:t>external 16-bit converter as the upgrade path. On the right is the thermistor</a:t>
+            </a:r>
+          </a:p>
+          <a:p>
+            <a:r>
+              <a:t>input. The useful thing here is that a fixed calibration error cancels out when</a:t>
+            </a:r>
+          </a:p>
+          <a:p>
+            <a:r>
+              <a:t>you take a derivative, so the rate trip is far less sensitive to ADC error than</a:t>
+            </a:r>
+          </a:p>
+          <a:p>
+            <a:r>
+              <a:t>an absolute reading would be.</a:t>
             </a:r>
           </a:p>
         </p:txBody>
@@ -5923,7 +5832,7 @@
                 </a:solidFill>
                 <a:latin typeface="Times New Roman"/>
               </a:rPr>
-              <a:t>Sensing Circuits</a:t>
+              <a:t>Protection and Balancing</a:t>
             </a:r>
           </a:p>
         </p:txBody>
@@ -6032,9 +5941,68 @@
           </a:p>
         </p:txBody>
       </p:sp>
+      <p:sp>
+        <p:nvSpPr>
+          <p:cNvPr id="7" name="TextBox 6"/>
+          <p:cNvSpPr txBox="1"/>
+          <p:nvPr/>
+        </p:nvSpPr>
+        <p:spPr>
+          <a:xfrm>
+            <a:off x="1168603" y="1298448"/>
+            <a:ext cx="10195560" cy="914400"/>
+          </a:xfrm>
+          <a:prstGeom prst="rect">
+            <a:avLst/>
+          </a:prstGeom>
+          <a:noFill/>
+        </p:spPr>
+        <p:txBody>
+          <a:bodyPr wrap="square" lIns="0" rIns="0" tIns="0" bIns="0">
+            <a:noAutofit/>
+          </a:bodyPr>
+          <a:lstStyle/>
+          <a:p>
+            <a:pPr marL="283464" indent="-283464">
+              <a:spcAft>
+                <a:spcPts val="600"/>
+              </a:spcAft>
+              <a:buFont typeface="Arial"/>
+              <a:buChar char="•"/>
+            </a:pPr>
+            <a:r>
+              <a:rPr sz="1700" b="0" i="0" u="none">
+                <a:solidFill>
+                  <a:srgbClr val="000000"/>
+                </a:solidFill>
+                <a:latin typeface="Times New Roman"/>
+              </a:rPr>
+              <a:t>IRLZ44N: logic level, 55 V, about 22 mΩ on-resistance at a 5 V gate</a:t>
+            </a:r>
+          </a:p>
+          <a:p>
+            <a:pPr marL="283464" indent="-283464">
+              <a:spcAft>
+                <a:spcPts val="600"/>
+              </a:spcAft>
+              <a:buFont typeface="Arial"/>
+              <a:buChar char="•"/>
+            </a:pPr>
+            <a:r>
+              <a:rPr sz="1700" b="0" i="0" u="none">
+                <a:solidFill>
+                  <a:srgbClr val="000000"/>
+                </a:solidFill>
+                <a:latin typeface="Times New Roman"/>
+              </a:rPr>
+              <a:t>The two body diodes face opposite ways, so each direction blocks separately</a:t>
+            </a:r>
+          </a:p>
+        </p:txBody>
+      </p:sp>
       <p:pic>
         <p:nvPicPr>
-          <p:cNvPr id="7" name="Picture 6" descr="04_voltage_sense_schematic.png"/>
+          <p:cNvPr id="8" name="Picture 7" descr="06_cutoff_balancing_schematic.png"/>
           <p:cNvPicPr>
             <a:picLocks noChangeAspect="1"/>
           </p:cNvPicPr>
@@ -6048,167 +6016,14 @@
         </p:blipFill>
         <p:spPr>
           <a:xfrm>
-            <a:off x="658368" y="1769728"/>
-            <a:ext cx="5230368" cy="2815622"/>
+            <a:off x="1468954" y="2267712"/>
+            <a:ext cx="9251042" cy="3858768"/>
           </a:xfrm>
           <a:prstGeom prst="rect">
             <a:avLst/>
           </a:prstGeom>
         </p:spPr>
       </p:pic>
-      <p:sp>
-        <p:nvSpPr>
-          <p:cNvPr id="8" name="TextBox 7"/>
-          <p:cNvSpPr txBox="1"/>
-          <p:nvPr/>
-        </p:nvSpPr>
-        <p:spPr>
-          <a:xfrm>
-            <a:off x="658368" y="1243584"/>
-            <a:ext cx="5230368" cy="310896"/>
-          </a:xfrm>
-          <a:prstGeom prst="rect">
-            <a:avLst/>
-          </a:prstGeom>
-          <a:noFill/>
-        </p:spPr>
-        <p:txBody>
-          <a:bodyPr wrap="square" lIns="0" rIns="0" tIns="0" bIns="0">
-            <a:noAutofit/>
-          </a:bodyPr>
-          <a:lstStyle/>
-          <a:p>
-            <a:pPr algn="ctr"/>
-            <a:r>
-              <a:rPr sz="1600" b="1" i="0" u="none">
-                <a:solidFill>
-                  <a:srgbClr val="000000"/>
-                </a:solidFill>
-                <a:latin typeface="Times New Roman"/>
-              </a:rPr>
-              <a:t>Cell voltage</a:t>
-            </a:r>
-          </a:p>
-        </p:txBody>
-      </p:sp>
-      <p:pic>
-        <p:nvPicPr>
-          <p:cNvPr id="9" name="Picture 8" descr="05_ntc_schematic.png"/>
-          <p:cNvPicPr>
-            <a:picLocks noChangeAspect="1"/>
-          </p:cNvPicPr>
-          <p:nvPr/>
-        </p:nvPicPr>
-        <p:blipFill>
-          <a:blip r:embed="rId4"/>
-          <a:stretch>
-            <a:fillRect/>
-          </a:stretch>
-        </p:blipFill>
-        <p:spPr>
-          <a:xfrm>
-            <a:off x="6300216" y="1970349"/>
-            <a:ext cx="5230368" cy="2414381"/>
-          </a:xfrm>
-          <a:prstGeom prst="rect">
-            <a:avLst/>
-          </a:prstGeom>
-        </p:spPr>
-      </p:pic>
-      <p:sp>
-        <p:nvSpPr>
-          <p:cNvPr id="10" name="TextBox 9"/>
-          <p:cNvSpPr txBox="1"/>
-          <p:nvPr/>
-        </p:nvSpPr>
-        <p:spPr>
-          <a:xfrm>
-            <a:off x="6300216" y="1243584"/>
-            <a:ext cx="5230368" cy="310896"/>
-          </a:xfrm>
-          <a:prstGeom prst="rect">
-            <a:avLst/>
-          </a:prstGeom>
-          <a:noFill/>
-        </p:spPr>
-        <p:txBody>
-          <a:bodyPr wrap="square" lIns="0" rIns="0" tIns="0" bIns="0">
-            <a:noAutofit/>
-          </a:bodyPr>
-          <a:lstStyle/>
-          <a:p>
-            <a:pPr algn="ctr"/>
-            <a:r>
-              <a:rPr sz="1600" b="1" i="0" u="none">
-                <a:solidFill>
-                  <a:srgbClr val="000000"/>
-                </a:solidFill>
-                <a:latin typeface="Times New Roman"/>
-              </a:rPr>
-              <a:t>Cell temperature</a:t>
-            </a:r>
-          </a:p>
-        </p:txBody>
-      </p:sp>
-      <p:sp>
-        <p:nvSpPr>
-          <p:cNvPr id="11" name="TextBox 10"/>
-          <p:cNvSpPr txBox="1"/>
-          <p:nvPr/>
-        </p:nvSpPr>
-        <p:spPr>
-          <a:xfrm>
-            <a:off x="1168603" y="4928616"/>
-            <a:ext cx="10195560" cy="1216152"/>
-          </a:xfrm>
-          <a:prstGeom prst="rect">
-            <a:avLst/>
-          </a:prstGeom>
-          <a:noFill/>
-        </p:spPr>
-        <p:txBody>
-          <a:bodyPr wrap="square" lIns="0" rIns="0" tIns="0" bIns="0">
-            <a:noAutofit/>
-          </a:bodyPr>
-          <a:lstStyle/>
-          <a:p>
-            <a:pPr marL="283464" indent="-283464">
-              <a:spcAft>
-                <a:spcPts val="800"/>
-              </a:spcAft>
-              <a:buFont typeface="Arial"/>
-              <a:buChar char="•"/>
-            </a:pPr>
-            <a:r>
-              <a:rPr sz="1700" b="0" i="0" u="none">
-                <a:solidFill>
-                  <a:srgbClr val="000000"/>
-                </a:solidFill>
-                <a:latin typeface="Times New Roman"/>
-              </a:rPr>
-              <a:t>Divider ratio 0.128 puts a full 16.8 V pack at 2.15 V — about 4.7 mV per count</a:t>
-            </a:r>
-          </a:p>
-          <a:p>
-            <a:pPr marL="283464" indent="-283464">
-              <a:spcAft>
-                <a:spcPts val="800"/>
-              </a:spcAft>
-              <a:buFont typeface="Arial"/>
-              <a:buChar char="•"/>
-            </a:pPr>
-            <a:r>
-              <a:rPr sz="1700" b="0" i="0" u="none">
-                <a:solidFill>
-                  <a:srgbClr val="000000"/>
-                </a:solidFill>
-                <a:latin typeface="Times New Roman"/>
-              </a:rPr>
-              <a:t>Beta equation: 1/T = 1/T₀ + (1/β)·ln(R/R₀), with T₀ = 298.15 K, R₀ = 10 kΩ, β = 3950 K</a:t>
-            </a:r>
-          </a:p>
-        </p:txBody>
-      </p:sp>
     </p:spTree>
   </p:cSld>
   <p:clrMapOvr>
@@ -6281,7 +6096,7 @@
                 </a:solidFill>
                 <a:latin typeface="Times New Roman"/>
               </a:rPr>
-              <a:t>Protection and Balancing</a:t>
+              <a:t>Firmware Architecture</a:t>
             </a:r>
           </a:p>
         </p:txBody>
@@ -6390,68 +6205,9 @@
           </a:p>
         </p:txBody>
       </p:sp>
-      <p:sp>
-        <p:nvSpPr>
-          <p:cNvPr id="7" name="TextBox 6"/>
-          <p:cNvSpPr txBox="1"/>
-          <p:nvPr/>
-        </p:nvSpPr>
-        <p:spPr>
-          <a:xfrm>
-            <a:off x="1168603" y="1298448"/>
-            <a:ext cx="10195560" cy="914400"/>
-          </a:xfrm>
-          <a:prstGeom prst="rect">
-            <a:avLst/>
-          </a:prstGeom>
-          <a:noFill/>
-        </p:spPr>
-        <p:txBody>
-          <a:bodyPr wrap="square" lIns="0" rIns="0" tIns="0" bIns="0">
-            <a:noAutofit/>
-          </a:bodyPr>
-          <a:lstStyle/>
-          <a:p>
-            <a:pPr marL="283464" indent="-283464">
-              <a:spcAft>
-                <a:spcPts val="600"/>
-              </a:spcAft>
-              <a:buFont typeface="Arial"/>
-              <a:buChar char="•"/>
-            </a:pPr>
-            <a:r>
-              <a:rPr sz="1700" b="0" i="0" u="none">
-                <a:solidFill>
-                  <a:srgbClr val="000000"/>
-                </a:solidFill>
-                <a:latin typeface="Times New Roman"/>
-              </a:rPr>
-              <a:t>IRLZ44N: logic level, 55 V, about 22 mΩ on-resistance at a 5 V gate</a:t>
-            </a:r>
-          </a:p>
-          <a:p>
-            <a:pPr marL="283464" indent="-283464">
-              <a:spcAft>
-                <a:spcPts val="600"/>
-              </a:spcAft>
-              <a:buFont typeface="Arial"/>
-              <a:buChar char="•"/>
-            </a:pPr>
-            <a:r>
-              <a:rPr sz="1700" b="0" i="0" u="none">
-                <a:solidFill>
-                  <a:srgbClr val="000000"/>
-                </a:solidFill>
-                <a:latin typeface="Times New Roman"/>
-              </a:rPr>
-              <a:t>The two body diodes face opposite ways, so each direction blocks separately</a:t>
-            </a:r>
-          </a:p>
-        </p:txBody>
-      </p:sp>
       <p:pic>
         <p:nvPicPr>
-          <p:cNvPr id="8" name="Picture 7" descr="06_cutoff_balancing_schematic.png"/>
+          <p:cNvPr id="7" name="Picture 6" descr="07_firmware_flowchart.png"/>
           <p:cNvPicPr>
             <a:picLocks noChangeAspect="1"/>
           </p:cNvPicPr>
@@ -6465,8 +6221,8 @@
         </p:blipFill>
         <p:spPr>
           <a:xfrm>
-            <a:off x="1468954" y="2267712"/>
-            <a:ext cx="9251042" cy="3858768"/>
+            <a:off x="889480" y="1298448"/>
+            <a:ext cx="10409990" cy="4828032"/>
           </a:xfrm>
           <a:prstGeom prst="rect">
             <a:avLst/>
@@ -6545,7 +6301,7 @@
                 </a:solidFill>
                 <a:latin typeface="Times New Roman"/>
               </a:rPr>
-              <a:t>Firmware Architecture</a:t>
+              <a:t>The Predictive Algorithm</a:t>
             </a:r>
           </a:p>
         </p:txBody>
@@ -6654,30 +6410,324 @@
           </a:p>
         </p:txBody>
       </p:sp>
-      <p:pic>
-        <p:nvPicPr>
-          <p:cNvPr id="7" name="Picture 6" descr="07_firmware_flowchart.png"/>
-          <p:cNvPicPr>
-            <a:picLocks noChangeAspect="1"/>
-          </p:cNvPicPr>
+      <p:sp>
+        <p:nvSpPr>
+          <p:cNvPr id="7" name="TextBox 6"/>
+          <p:cNvSpPr txBox="1"/>
           <p:nvPr/>
-        </p:nvPicPr>
-        <p:blipFill>
-          <a:blip r:embed="rId3"/>
-          <a:stretch>
-            <a:fillRect/>
-          </a:stretch>
-        </p:blipFill>
-        <p:spPr>
-          <a:xfrm>
-            <a:off x="889480" y="1298448"/>
-            <a:ext cx="10409990" cy="4828032"/>
-          </a:xfrm>
-          <a:prstGeom prst="rect">
-            <a:avLst/>
-          </a:prstGeom>
-        </p:spPr>
-      </p:pic>
+        </p:nvSpPr>
+        <p:spPr>
+          <a:xfrm>
+            <a:off x="1168603" y="1389888"/>
+            <a:ext cx="10195560" cy="777240"/>
+          </a:xfrm>
+          <a:prstGeom prst="rect">
+            <a:avLst/>
+          </a:prstGeom>
+          <a:noFill/>
+        </p:spPr>
+        <p:txBody>
+          <a:bodyPr wrap="square" lIns="0" rIns="0" tIns="0" bIns="0">
+            <a:noAutofit/>
+          </a:bodyPr>
+          <a:lstStyle/>
+          <a:p>
+            <a:pPr marL="283464" indent="-283464">
+              <a:spcAft>
+                <a:spcPts val="600"/>
+              </a:spcAft>
+              <a:buFont typeface="Arial"/>
+              <a:buChar char="•"/>
+            </a:pPr>
+            <a:r>
+              <a:rPr sz="1700" b="0" i="0" u="none">
+                <a:solidFill>
+                  <a:srgbClr val="000000"/>
+                </a:solidFill>
+                <a:latin typeface="Times New Roman"/>
+              </a:rPr>
+              <a:t>Temperature is sampled every 100 ms and smoothed before the slope is taken</a:t>
+            </a:r>
+          </a:p>
+          <a:p>
+            <a:pPr marL="283464" indent="-283464">
+              <a:spcAft>
+                <a:spcPts val="600"/>
+              </a:spcAft>
+              <a:buFont typeface="Arial"/>
+              <a:buChar char="•"/>
+            </a:pPr>
+            <a:r>
+              <a:rPr sz="1700" b="0" i="0" u="none">
+                <a:solidFill>
+                  <a:srgbClr val="000000"/>
+                </a:solidFill>
+                <a:latin typeface="Times New Roman"/>
+              </a:rPr>
+              <a:t>The slope is an exponential moving average over a one-second window</a:t>
+            </a:r>
+          </a:p>
+        </p:txBody>
+      </p:sp>
+      <p:sp>
+        <p:nvSpPr>
+          <p:cNvPr id="8" name="TextBox 7"/>
+          <p:cNvSpPr txBox="1"/>
+          <p:nvPr/>
+        </p:nvSpPr>
+        <p:spPr>
+          <a:xfrm>
+            <a:off x="1671523" y="2395728"/>
+            <a:ext cx="9189720" cy="2714243"/>
+          </a:xfrm>
+          <a:prstGeom prst="rect">
+            <a:avLst/>
+          </a:prstGeom>
+          <a:solidFill>
+            <a:srgbClr val="F5F5F5"/>
+          </a:solidFill>
+          <a:ln>
+            <a:solidFill>
+              <a:srgbClr val="D8D8D8"/>
+            </a:solidFill>
+          </a:ln>
+        </p:spPr>
+        <p:txBody>
+          <a:bodyPr wrap="none" lIns="146304" rIns="146304" tIns="91440" bIns="91440">
+            <a:noAutofit/>
+          </a:bodyPr>
+          <a:lstStyle/>
+          <a:p>
+            <a:pPr>
+              <a:spcAft>
+                <a:spcPts val="0"/>
+              </a:spcAft>
+              <a:buNone/>
+            </a:pPr>
+            <a:r>
+              <a:rPr sz="1500" b="0" i="0" u="none">
+                <a:solidFill>
+                  <a:srgbClr val="000000"/>
+                </a:solidFill>
+                <a:latin typeface="Consolas"/>
+              </a:rPr>
+              <a:t>T_filt  = ema(T_raw, alpha = 0.2)</a:t>
+            </a:r>
+          </a:p>
+          <a:p>
+            <a:pPr>
+              <a:spcAft>
+                <a:spcPts val="0"/>
+              </a:spcAft>
+              <a:buNone/>
+            </a:pPr>
+            <a:r>
+              <a:rPr sz="1500" b="0" i="0" u="none">
+                <a:solidFill>
+                  <a:srgbClr val="000000"/>
+                </a:solidFill>
+                <a:latin typeface="Consolas"/>
+              </a:rPr>
+              <a:t>slope   = (T_filt - T_filt_1s_ago) / 1.0</a:t>
+            </a:r>
+          </a:p>
+          <a:p>
+            <a:pPr>
+              <a:spcAft>
+                <a:spcPts val="0"/>
+              </a:spcAft>
+              <a:buNone/>
+            </a:pPr>
+            <a:r>
+              <a:rPr sz="1500" b="0" i="0" u="none">
+                <a:solidFill>
+                  <a:srgbClr val="000000"/>
+                </a:solidFill>
+                <a:latin typeface="Consolas"/>
+              </a:rPr>
+              <a:t>dTdt    = ema(slope, alpha = 0.3)</a:t>
+            </a:r>
+          </a:p>
+          <a:p>
+            <a:pPr>
+              <a:spcAft>
+                <a:spcPts val="0"/>
+              </a:spcAft>
+              <a:buNone/>
+            </a:pPr>
+            <a:r>
+              <a:rPr sz="1500" b="0" i="0" u="none">
+                <a:solidFill>
+                  <a:srgbClr val="000000"/>
+                </a:solidFill>
+                <a:latin typeface="Consolas"/>
+              </a:rPr>
+              <a:t/>
+            </a:r>
+          </a:p>
+          <a:p>
+            <a:pPr>
+              <a:spcAft>
+                <a:spcPts val="0"/>
+              </a:spcAft>
+              <a:buNone/>
+            </a:pPr>
+            <a:r>
+              <a:rPr sz="1500" b="0" i="0" u="none">
+                <a:solidFill>
+                  <a:srgbClr val="000000"/>
+                </a:solidFill>
+                <a:latin typeface="Consolas"/>
+              </a:rPr>
+              <a:t>if dTdt &gt;= 1.0 or T_filt &gt;= 60.0:</a:t>
+            </a:r>
+          </a:p>
+          <a:p>
+            <a:pPr>
+              <a:spcAft>
+                <a:spcPts val="0"/>
+              </a:spcAft>
+              <a:buNone/>
+            </a:pPr>
+            <a:r>
+              <a:rPr sz="1500" b="0" i="0" u="none">
+                <a:solidFill>
+                  <a:srgbClr val="000000"/>
+                </a:solidFill>
+                <a:latin typeface="Consolas"/>
+              </a:rPr>
+              <a:t>    open_both_mosfets()</a:t>
+            </a:r>
+          </a:p>
+          <a:p>
+            <a:pPr>
+              <a:spcAft>
+                <a:spcPts val="0"/>
+              </a:spcAft>
+              <a:buNone/>
+            </a:pPr>
+            <a:r>
+              <a:rPr sz="1500" b="0" i="0" u="none">
+                <a:solidFill>
+                  <a:srgbClr val="000000"/>
+                </a:solidFill>
+                <a:latin typeface="Consolas"/>
+              </a:rPr>
+              <a:t>    state = CUTOFF</a:t>
+            </a:r>
+          </a:p>
+          <a:p>
+            <a:pPr>
+              <a:spcAft>
+                <a:spcPts val="0"/>
+              </a:spcAft>
+              <a:buNone/>
+            </a:pPr>
+            <a:r>
+              <a:rPr sz="1500" b="0" i="0" u="none">
+                <a:solidFill>
+                  <a:srgbClr val="000000"/>
+                </a:solidFill>
+                <a:latin typeface="Consolas"/>
+              </a:rPr>
+              <a:t>elif dTdt &gt;= 0.5:</a:t>
+            </a:r>
+          </a:p>
+          <a:p>
+            <a:pPr>
+              <a:spcAft>
+                <a:spcPts val="0"/>
+              </a:spcAft>
+              <a:buNone/>
+            </a:pPr>
+            <a:r>
+              <a:rPr sz="1500" b="0" i="0" u="none">
+                <a:solidFill>
+                  <a:srgbClr val="000000"/>
+                </a:solidFill>
+                <a:latin typeface="Consolas"/>
+              </a:rPr>
+              <a:t>    state = WARNING</a:t>
+            </a:r>
+          </a:p>
+          <a:p>
+            <a:pPr>
+              <a:spcAft>
+                <a:spcPts val="0"/>
+              </a:spcAft>
+              <a:buNone/>
+            </a:pPr>
+            <a:r>
+              <a:rPr sz="1500" b="0" i="0" u="none">
+                <a:solidFill>
+                  <a:srgbClr val="000000"/>
+                </a:solidFill>
+                <a:latin typeface="Consolas"/>
+              </a:rPr>
+              <a:t># leave CUTOFF only when dTdt &lt; 0.2 and T_filt &lt; 40 for 5 s</a:t>
+            </a:r>
+          </a:p>
+        </p:txBody>
+      </p:sp>
+      <p:sp>
+        <p:nvSpPr>
+          <p:cNvPr id="9" name="TextBox 8"/>
+          <p:cNvSpPr txBox="1"/>
+          <p:nvPr/>
+        </p:nvSpPr>
+        <p:spPr>
+          <a:xfrm>
+            <a:off x="1168603" y="5384291"/>
+            <a:ext cx="10195560" cy="760476"/>
+          </a:xfrm>
+          <a:prstGeom prst="rect">
+            <a:avLst/>
+          </a:prstGeom>
+          <a:noFill/>
+        </p:spPr>
+        <p:txBody>
+          <a:bodyPr wrap="square" lIns="0" rIns="0" tIns="0" bIns="0">
+            <a:noAutofit/>
+          </a:bodyPr>
+          <a:lstStyle/>
+          <a:p>
+            <a:pPr marL="283464" indent="-283464">
+              <a:spcAft>
+                <a:spcPts val="800"/>
+              </a:spcAft>
+              <a:buFont typeface="Arial"/>
+              <a:buChar char="•"/>
+            </a:pPr>
+            <a:r>
+              <a:rPr sz="1700" b="0" i="0" u="none">
+                <a:solidFill>
+                  <a:srgbClr val="000000"/>
+                </a:solidFill>
+                <a:latin typeface="Times New Roman"/>
+              </a:rPr>
+              <a:t>Smoothing comes first: a slope taken from raw counts is mostly noise</a:t>
+            </a:r>
+          </a:p>
+          <a:p>
+            <a:pPr marL="283464" indent="-283464">
+              <a:spcAft>
+                <a:spcPts val="800"/>
+              </a:spcAft>
+              <a:buFont typeface="Arial"/>
+              <a:buChar char="•"/>
+            </a:pPr>
+            <a:r>
+              <a:rPr sz="1700" b="0" i="0" u="none">
+                <a:solidFill>
+                  <a:srgbClr val="000000"/>
+                </a:solidFill>
+                <a:latin typeface="Times New Roman"/>
+              </a:rPr>
+              <a:t>A fixed calibration error cancels in a slope, so the trip tolerates ADC drift</a:t>
+            </a:r>
+          </a:p>
+        </p:txBody>
+      </p:sp>
     </p:spTree>
   </p:cSld>
   <p:clrMapOvr>
@@ -6750,7 +6800,7 @@
                 </a:solidFill>
                 <a:latin typeface="Times New Roman"/>
               </a:rPr>
-              <a:t>The Predictive Algorithm</a:t>
+              <a:t>Predictive Compared With a Fixed Limit</a:t>
             </a:r>
           </a:p>
         </p:txBody>
@@ -6859,16 +6909,40 @@
           </a:p>
         </p:txBody>
       </p:sp>
-      <p:sp>
-        <p:nvSpPr>
-          <p:cNvPr id="7" name="TextBox 6"/>
+      <p:pic>
+        <p:nvPicPr>
+          <p:cNvPr id="7" name="Picture 6" descr="08_predictive_vs_reactive.png"/>
+          <p:cNvPicPr>
+            <a:picLocks noChangeAspect="1"/>
+          </p:cNvPicPr>
+          <p:nvPr/>
+        </p:nvPicPr>
+        <p:blipFill>
+          <a:blip r:embed="rId3"/>
+          <a:stretch>
+            <a:fillRect/>
+          </a:stretch>
+        </p:blipFill>
+        <p:spPr>
+          <a:xfrm>
+            <a:off x="1626599" y="1298448"/>
+            <a:ext cx="8935752" cy="4443984"/>
+          </a:xfrm>
+          <a:prstGeom prst="rect">
+            <a:avLst/>
+          </a:prstGeom>
+        </p:spPr>
+      </p:pic>
+      <p:sp>
+        <p:nvSpPr>
+          <p:cNvPr id="8" name="TextBox 7"/>
           <p:cNvSpPr txBox="1"/>
           <p:nvPr/>
         </p:nvSpPr>
         <p:spPr>
           <a:xfrm>
-            <a:off x="1168603" y="1389888"/>
-            <a:ext cx="10195560" cy="777240"/>
+            <a:off x="1168603" y="5797296"/>
+            <a:ext cx="10195560" cy="310896"/>
           </a:xfrm>
           <a:prstGeom prst="rect">
             <a:avLst/>
@@ -6881,298 +6955,15 @@
           </a:bodyPr>
           <a:lstStyle/>
           <a:p>
-            <a:pPr marL="283464" indent="-283464">
-              <a:spcAft>
-                <a:spcPts val="600"/>
-              </a:spcAft>
-              <a:buFont typeface="Arial"/>
-              <a:buChar char="•"/>
-            </a:pPr>
-            <a:r>
-              <a:rPr sz="1700" b="0" i="0" u="none">
-                <a:solidFill>
-                  <a:srgbClr val="000000"/>
+            <a:pPr algn="ctr"/>
+            <a:r>
+              <a:rPr sz="1400" b="0" i="1" u="none">
+                <a:solidFill>
+                  <a:srgbClr val="898989"/>
                 </a:solidFill>
                 <a:latin typeface="Times New Roman"/>
               </a:rPr>
-              <a:t>Temperature is sampled every 100 ms and smoothed before the slope is taken</a:t>
-            </a:r>
-          </a:p>
-          <a:p>
-            <a:pPr marL="283464" indent="-283464">
-              <a:spcAft>
-                <a:spcPts val="600"/>
-              </a:spcAft>
-              <a:buFont typeface="Arial"/>
-              <a:buChar char="•"/>
-            </a:pPr>
-            <a:r>
-              <a:rPr sz="1700" b="0" i="0" u="none">
-                <a:solidFill>
-                  <a:srgbClr val="000000"/>
-                </a:solidFill>
-                <a:latin typeface="Times New Roman"/>
-              </a:rPr>
-              <a:t>The slope is an exponential moving average over a one-second window</a:t>
-            </a:r>
-          </a:p>
-        </p:txBody>
-      </p:sp>
-      <p:sp>
-        <p:nvSpPr>
-          <p:cNvPr id="8" name="TextBox 7"/>
-          <p:cNvSpPr txBox="1"/>
-          <p:nvPr/>
-        </p:nvSpPr>
-        <p:spPr>
-          <a:xfrm>
-            <a:off x="1671523" y="2395728"/>
-            <a:ext cx="9189720" cy="2714243"/>
-          </a:xfrm>
-          <a:prstGeom prst="rect">
-            <a:avLst/>
-          </a:prstGeom>
-          <a:solidFill>
-            <a:srgbClr val="F5F5F5"/>
-          </a:solidFill>
-          <a:ln>
-            <a:solidFill>
-              <a:srgbClr val="D8D8D8"/>
-            </a:solidFill>
-          </a:ln>
-        </p:spPr>
-        <p:txBody>
-          <a:bodyPr wrap="none" lIns="146304" rIns="146304" tIns="91440" bIns="91440">
-            <a:noAutofit/>
-          </a:bodyPr>
-          <a:lstStyle/>
-          <a:p>
-            <a:pPr>
-              <a:spcAft>
-                <a:spcPts val="0"/>
-              </a:spcAft>
-              <a:buNone/>
-            </a:pPr>
-            <a:r>
-              <a:rPr sz="1500" b="0" i="0" u="none">
-                <a:solidFill>
-                  <a:srgbClr val="000000"/>
-                </a:solidFill>
-                <a:latin typeface="Consolas"/>
-              </a:rPr>
-              <a:t>T_filt  = ema(T_raw, alpha = 0.2)</a:t>
-            </a:r>
-          </a:p>
-          <a:p>
-            <a:pPr>
-              <a:spcAft>
-                <a:spcPts val="0"/>
-              </a:spcAft>
-              <a:buNone/>
-            </a:pPr>
-            <a:r>
-              <a:rPr sz="1500" b="0" i="0" u="none">
-                <a:solidFill>
-                  <a:srgbClr val="000000"/>
-                </a:solidFill>
-                <a:latin typeface="Consolas"/>
-              </a:rPr>
-              <a:t>slope   = (T_filt - T_filt_1s_ago) / 1.0</a:t>
-            </a:r>
-          </a:p>
-          <a:p>
-            <a:pPr>
-              <a:spcAft>
-                <a:spcPts val="0"/>
-              </a:spcAft>
-              <a:buNone/>
-            </a:pPr>
-            <a:r>
-              <a:rPr sz="1500" b="0" i="0" u="none">
-                <a:solidFill>
-                  <a:srgbClr val="000000"/>
-                </a:solidFill>
-                <a:latin typeface="Consolas"/>
-              </a:rPr>
-              <a:t>dTdt    = ema(slope, alpha = 0.3)</a:t>
-            </a:r>
-          </a:p>
-          <a:p>
-            <a:pPr>
-              <a:spcAft>
-                <a:spcPts val="0"/>
-              </a:spcAft>
-              <a:buNone/>
-            </a:pPr>
-            <a:r>
-              <a:rPr sz="1500" b="0" i="0" u="none">
-                <a:solidFill>
-                  <a:srgbClr val="000000"/>
-                </a:solidFill>
-                <a:latin typeface="Consolas"/>
-              </a:rPr>
-              <a:t/>
-            </a:r>
-          </a:p>
-          <a:p>
-            <a:pPr>
-              <a:spcAft>
-                <a:spcPts val="0"/>
-              </a:spcAft>
-              <a:buNone/>
-            </a:pPr>
-            <a:r>
-              <a:rPr sz="1500" b="0" i="0" u="none">
-                <a:solidFill>
-                  <a:srgbClr val="000000"/>
-                </a:solidFill>
-                <a:latin typeface="Consolas"/>
-              </a:rPr>
-              <a:t>if dTdt &gt;= 1.0 or T_filt &gt;= 60.0:</a:t>
-            </a:r>
-          </a:p>
-          <a:p>
-            <a:pPr>
-              <a:spcAft>
-                <a:spcPts val="0"/>
-              </a:spcAft>
-              <a:buNone/>
-            </a:pPr>
-            <a:r>
-              <a:rPr sz="1500" b="0" i="0" u="none">
-                <a:solidFill>
-                  <a:srgbClr val="000000"/>
-                </a:solidFill>
-                <a:latin typeface="Consolas"/>
-              </a:rPr>
-              <a:t>    open_both_mosfets()</a:t>
-            </a:r>
-          </a:p>
-          <a:p>
-            <a:pPr>
-              <a:spcAft>
-                <a:spcPts val="0"/>
-              </a:spcAft>
-              <a:buNone/>
-            </a:pPr>
-            <a:r>
-              <a:rPr sz="1500" b="0" i="0" u="none">
-                <a:solidFill>
-                  <a:srgbClr val="000000"/>
-                </a:solidFill>
-                <a:latin typeface="Consolas"/>
-              </a:rPr>
-              <a:t>    state = CUTOFF</a:t>
-            </a:r>
-          </a:p>
-          <a:p>
-            <a:pPr>
-              <a:spcAft>
-                <a:spcPts val="0"/>
-              </a:spcAft>
-              <a:buNone/>
-            </a:pPr>
-            <a:r>
-              <a:rPr sz="1500" b="0" i="0" u="none">
-                <a:solidFill>
-                  <a:srgbClr val="000000"/>
-                </a:solidFill>
-                <a:latin typeface="Consolas"/>
-              </a:rPr>
-              <a:t>elif dTdt &gt;= 0.5:</a:t>
-            </a:r>
-          </a:p>
-          <a:p>
-            <a:pPr>
-              <a:spcAft>
-                <a:spcPts val="0"/>
-              </a:spcAft>
-              <a:buNone/>
-            </a:pPr>
-            <a:r>
-              <a:rPr sz="1500" b="0" i="0" u="none">
-                <a:solidFill>
-                  <a:srgbClr val="000000"/>
-                </a:solidFill>
-                <a:latin typeface="Consolas"/>
-              </a:rPr>
-              <a:t>    state = WARNING</a:t>
-            </a:r>
-          </a:p>
-          <a:p>
-            <a:pPr>
-              <a:spcAft>
-                <a:spcPts val="0"/>
-              </a:spcAft>
-              <a:buNone/>
-            </a:pPr>
-            <a:r>
-              <a:rPr sz="1500" b="0" i="0" u="none">
-                <a:solidFill>
-                  <a:srgbClr val="000000"/>
-                </a:solidFill>
-                <a:latin typeface="Consolas"/>
-              </a:rPr>
-              <a:t># leave CUTOFF only when dTdt &lt; 0.2 and T_filt &lt; 40 for 5 s</a:t>
-            </a:r>
-          </a:p>
-        </p:txBody>
-      </p:sp>
-      <p:sp>
-        <p:nvSpPr>
-          <p:cNvPr id="9" name="TextBox 8"/>
-          <p:cNvSpPr txBox="1"/>
-          <p:nvPr/>
-        </p:nvSpPr>
-        <p:spPr>
-          <a:xfrm>
-            <a:off x="1168603" y="5384291"/>
-            <a:ext cx="10195560" cy="760476"/>
-          </a:xfrm>
-          <a:prstGeom prst="rect">
-            <a:avLst/>
-          </a:prstGeom>
-          <a:noFill/>
-        </p:spPr>
-        <p:txBody>
-          <a:bodyPr wrap="square" lIns="0" rIns="0" tIns="0" bIns="0">
-            <a:noAutofit/>
-          </a:bodyPr>
-          <a:lstStyle/>
-          <a:p>
-            <a:pPr marL="283464" indent="-283464">
-              <a:spcAft>
-                <a:spcPts val="800"/>
-              </a:spcAft>
-              <a:buFont typeface="Arial"/>
-              <a:buChar char="•"/>
-            </a:pPr>
-            <a:r>
-              <a:rPr sz="1700" b="0" i="0" u="none">
-                <a:solidFill>
-                  <a:srgbClr val="000000"/>
-                </a:solidFill>
-                <a:latin typeface="Times New Roman"/>
-              </a:rPr>
-              <a:t>Smoothing comes first: a slope taken from raw counts is mostly noise</a:t>
-            </a:r>
-          </a:p>
-          <a:p>
-            <a:pPr marL="283464" indent="-283464">
-              <a:spcAft>
-                <a:spcPts val="800"/>
-              </a:spcAft>
-              <a:buFont typeface="Arial"/>
-              <a:buChar char="•"/>
-            </a:pPr>
-            <a:r>
-              <a:rPr sz="1700" b="0" i="0" u="none">
-                <a:solidFill>
-                  <a:srgbClr val="000000"/>
-                </a:solidFill>
-                <a:latin typeface="Times New Roman"/>
-              </a:rPr>
-              <a:t>A fixed calibration error cancels in a slope, so the trip tolerates ADC drift</a:t>
+              <a:t>Simulated for illustration. Real measurements will replace this after bench testing.</a:t>
             </a:r>
           </a:p>
         </p:txBody>
@@ -7249,7 +7040,7 @@
                 </a:solidFill>
                 <a:latin typeface="Times New Roman"/>
               </a:rPr>
-              <a:t>Predictive Compared With a Fixed Limit</a:t>
+              <a:t>IoT Dashboard</a:t>
             </a:r>
           </a:p>
         </p:txBody>
@@ -7360,7 +7151,7 @@
       </p:sp>
       <p:pic>
         <p:nvPicPr>
-          <p:cNvPr id="7" name="Picture 6" descr="08_predictive_vs_reactive.png"/>
+          <p:cNvPr id="7" name="Picture 6" descr="09_iot_architecture.png"/>
           <p:cNvPicPr>
             <a:picLocks noChangeAspect="1"/>
           </p:cNvPicPr>
@@ -7374,49 +7165,14 @@
         </p:blipFill>
         <p:spPr>
           <a:xfrm>
-            <a:off x="1626599" y="1298448"/>
-            <a:ext cx="8935752" cy="4443984"/>
+            <a:off x="658368" y="1381810"/>
+            <a:ext cx="10872215" cy="4661306"/>
           </a:xfrm>
           <a:prstGeom prst="rect">
             <a:avLst/>
           </a:prstGeom>
         </p:spPr>
       </p:pic>
-      <p:sp>
-        <p:nvSpPr>
-          <p:cNvPr id="8" name="TextBox 7"/>
-          <p:cNvSpPr txBox="1"/>
-          <p:nvPr/>
-        </p:nvSpPr>
-        <p:spPr>
-          <a:xfrm>
-            <a:off x="1168603" y="5797296"/>
-            <a:ext cx="10195560" cy="310896"/>
-          </a:xfrm>
-          <a:prstGeom prst="rect">
-            <a:avLst/>
-          </a:prstGeom>
-          <a:noFill/>
-        </p:spPr>
-        <p:txBody>
-          <a:bodyPr wrap="square" lIns="0" rIns="0" tIns="0" bIns="0">
-            <a:noAutofit/>
-          </a:bodyPr>
-          <a:lstStyle/>
-          <a:p>
-            <a:pPr algn="ctr"/>
-            <a:r>
-              <a:rPr sz="1400" b="0" i="1" u="none">
-                <a:solidFill>
-                  <a:srgbClr val="898989"/>
-                </a:solidFill>
-                <a:latin typeface="Times New Roman"/>
-              </a:rPr>
-              <a:t>Simulated for illustration. Real measurements will replace this after bench testing.</a:t>
-            </a:r>
-          </a:p>
-        </p:txBody>
-      </p:sp>
     </p:spTree>
   </p:cSld>
   <p:clrMapOvr>
@@ -7489,7 +7245,7 @@
                 </a:solidFill>
                 <a:latin typeface="Times New Roman"/>
               </a:rPr>
-              <a:t>IoT Dashboard</a:t>
+              <a:t>Bill of Materials</a:t>
             </a:r>
           </a:p>
         </p:txBody>
@@ -7594,211 +7350,6 @@
                 <a:latin typeface="Calibri"/>
               </a:rPr>
               <a:t>15</a:t>
-            </a:r>
-          </a:p>
-        </p:txBody>
-      </p:sp>
-      <p:pic>
-        <p:nvPicPr>
-          <p:cNvPr id="7" name="Picture 6" descr="09_iot_architecture.png"/>
-          <p:cNvPicPr>
-            <a:picLocks noChangeAspect="1"/>
-          </p:cNvPicPr>
-          <p:nvPr/>
-        </p:nvPicPr>
-        <p:blipFill>
-          <a:blip r:embed="rId3"/>
-          <a:stretch>
-            <a:fillRect/>
-          </a:stretch>
-        </p:blipFill>
-        <p:spPr>
-          <a:xfrm>
-            <a:off x="658368" y="1381810"/>
-            <a:ext cx="10872215" cy="4661306"/>
-          </a:xfrm>
-          <a:prstGeom prst="rect">
-            <a:avLst/>
-          </a:prstGeom>
-        </p:spPr>
-      </p:pic>
-    </p:spTree>
-  </p:cSld>
-  <p:clrMapOvr>
-    <a:masterClrMapping/>
-  </p:clrMapOvr>
-</p:sld>
-</file>
-
-<file path=ppt/slides/slide16.xml><?xml version="1.0" encoding="utf-8"?>
-<p:sld xmlns:a="http://schemas.openxmlformats.org/drawingml/2006/main" xmlns:p="http://schemas.openxmlformats.org/presentationml/2006/main" xmlns:r="http://schemas.openxmlformats.org/officeDocument/2006/relationships">
-  <p:cSld>
-    <p:spTree>
-      <p:nvGrpSpPr>
-        <p:cNvPr id="1" name=""/>
-        <p:cNvGrpSpPr/>
-        <p:nvPr/>
-      </p:nvGrpSpPr>
-      <p:grpSpPr/>
-      <p:pic>
-        <p:nvPicPr>
-          <p:cNvPr id="2" name="Picture 1" descr="logo.png"/>
-          <p:cNvPicPr>
-            <a:picLocks noChangeAspect="1"/>
-          </p:cNvPicPr>
-          <p:nvPr/>
-        </p:nvPicPr>
-        <p:blipFill>
-          <a:blip r:embed="rId2"/>
-          <a:stretch>
-            <a:fillRect/>
-          </a:stretch>
-        </p:blipFill>
-        <p:spPr>
-          <a:xfrm>
-            <a:off x="286207" y="109728"/>
-            <a:ext cx="646480" cy="950976"/>
-          </a:xfrm>
-          <a:prstGeom prst="rect">
-            <a:avLst/>
-          </a:prstGeom>
-        </p:spPr>
-      </p:pic>
-      <p:sp>
-        <p:nvSpPr>
-          <p:cNvPr id="3" name="TextBox 2"/>
-          <p:cNvSpPr txBox="1"/>
-          <p:nvPr/>
-        </p:nvSpPr>
-        <p:spPr>
-          <a:xfrm>
-            <a:off x="1188720" y="384048"/>
-            <a:ext cx="9814255" cy="548640"/>
-          </a:xfrm>
-          <a:prstGeom prst="rect">
-            <a:avLst/>
-          </a:prstGeom>
-          <a:noFill/>
-        </p:spPr>
-        <p:txBody>
-          <a:bodyPr wrap="square" lIns="0" rIns="0" tIns="0" bIns="0">
-            <a:noAutofit/>
-          </a:bodyPr>
-          <a:lstStyle/>
-          <a:p>
-            <a:pPr algn="ctr"/>
-            <a:r>
-              <a:rPr sz="2400" b="1" i="0" u="sng">
-                <a:solidFill>
-                  <a:srgbClr val="000000"/>
-                </a:solidFill>
-                <a:latin typeface="Times New Roman"/>
-              </a:rPr>
-              <a:t>Bill of Materials</a:t>
-            </a:r>
-          </a:p>
-        </p:txBody>
-      </p:sp>
-      <p:sp>
-        <p:nvSpPr>
-          <p:cNvPr id="4" name="TextBox 3"/>
-          <p:cNvSpPr txBox="1"/>
-          <p:nvPr/>
-        </p:nvSpPr>
-        <p:spPr>
-          <a:xfrm>
-            <a:off x="929944" y="6355080"/>
-            <a:ext cx="2286000" cy="292608"/>
-          </a:xfrm>
-          <a:prstGeom prst="rect">
-            <a:avLst/>
-          </a:prstGeom>
-          <a:noFill/>
-        </p:spPr>
-        <p:txBody>
-          <a:bodyPr wrap="square" lIns="0" rIns="0" tIns="0" bIns="0">
-            <a:noAutofit/>
-          </a:bodyPr>
-          <a:lstStyle/>
-          <a:p>
-            <a:r>
-              <a:rPr sz="1200" b="0" i="0" u="none">
-                <a:solidFill>
-                  <a:srgbClr val="898989"/>
-                </a:solidFill>
-                <a:latin typeface="Calibri"/>
-              </a:rPr>
-              <a:t>27-08-2026</a:t>
-            </a:r>
-          </a:p>
-        </p:txBody>
-      </p:sp>
-      <p:sp>
-        <p:nvSpPr>
-          <p:cNvPr id="5" name="TextBox 4"/>
-          <p:cNvSpPr txBox="1"/>
-          <p:nvPr/>
-        </p:nvSpPr>
-        <p:spPr>
-          <a:xfrm>
-            <a:off x="3931920" y="6355080"/>
-            <a:ext cx="4297680" cy="292608"/>
-          </a:xfrm>
-          <a:prstGeom prst="rect">
-            <a:avLst/>
-          </a:prstGeom>
-          <a:noFill/>
-        </p:spPr>
-        <p:txBody>
-          <a:bodyPr wrap="square" lIns="0" rIns="0" tIns="0" bIns="0">
-            <a:noAutofit/>
-          </a:bodyPr>
-          <a:lstStyle/>
-          <a:p>
-            <a:pPr algn="ctr"/>
-            <a:r>
-              <a:rPr sz="1200" b="0" i="0" u="none">
-                <a:solidFill>
-                  <a:srgbClr val="898989"/>
-                </a:solidFill>
-                <a:latin typeface="Calibri"/>
-              </a:rPr>
-              <a:t>First Review-2026-27</a:t>
-            </a:r>
-          </a:p>
-        </p:txBody>
-      </p:sp>
-      <p:sp>
-        <p:nvSpPr>
-          <p:cNvPr id="6" name="TextBox 5"/>
-          <p:cNvSpPr txBox="1"/>
-          <p:nvPr/>
-        </p:nvSpPr>
-        <p:spPr>
-          <a:xfrm>
-            <a:off x="10058400" y="6355080"/>
-            <a:ext cx="1204264" cy="292608"/>
-          </a:xfrm>
-          <a:prstGeom prst="rect">
-            <a:avLst/>
-          </a:prstGeom>
-          <a:noFill/>
-        </p:spPr>
-        <p:txBody>
-          <a:bodyPr wrap="square" lIns="0" rIns="0" tIns="0" bIns="0">
-            <a:noAutofit/>
-          </a:bodyPr>
-          <a:lstStyle/>
-          <a:p>
-            <a:pPr algn="r"/>
-            <a:r>
-              <a:rPr sz="1200" b="0" i="0" u="none">
-                <a:solidFill>
-                  <a:srgbClr val="898989"/>
-                </a:solidFill>
-                <a:latin typeface="Calibri"/>
-              </a:rPr>
-              <a:t>16</a:t>
             </a:r>
           </a:p>
         </p:txBody>
@@ -9002,7 +8553,7 @@
 </p:sld>
 </file>
 
-<file path=ppt/slides/slide17.xml><?xml version="1.0" encoding="utf-8"?>
+<file path=ppt/slides/slide16.xml><?xml version="1.0" encoding="utf-8"?>
 <p:sld xmlns:a="http://schemas.openxmlformats.org/drawingml/2006/main" xmlns:p="http://schemas.openxmlformats.org/presentationml/2006/main" xmlns:r="http://schemas.openxmlformats.org/officeDocument/2006/relationships">
   <p:cSld>
     <p:spTree>
@@ -9170,7 +8721,7 @@
                 </a:solidFill>
                 <a:latin typeface="Calibri"/>
               </a:rPr>
-              <a:t>17</a:t>
+              <a:t>16</a:t>
             </a:r>
           </a:p>
         </p:txBody>
@@ -9707,6 +9258,211 @@
 </p:sld>
 </file>
 
+<file path=ppt/slides/slide17.xml><?xml version="1.0" encoding="utf-8"?>
+<p:sld xmlns:a="http://schemas.openxmlformats.org/drawingml/2006/main" xmlns:p="http://schemas.openxmlformats.org/presentationml/2006/main" xmlns:r="http://schemas.openxmlformats.org/officeDocument/2006/relationships">
+  <p:cSld>
+    <p:spTree>
+      <p:nvGrpSpPr>
+        <p:cNvPr id="1" name=""/>
+        <p:cNvGrpSpPr/>
+        <p:nvPr/>
+      </p:nvGrpSpPr>
+      <p:grpSpPr/>
+      <p:pic>
+        <p:nvPicPr>
+          <p:cNvPr id="2" name="Picture 1" descr="logo.png"/>
+          <p:cNvPicPr>
+            <a:picLocks noChangeAspect="1"/>
+          </p:cNvPicPr>
+          <p:nvPr/>
+        </p:nvPicPr>
+        <p:blipFill>
+          <a:blip r:embed="rId2"/>
+          <a:stretch>
+            <a:fillRect/>
+          </a:stretch>
+        </p:blipFill>
+        <p:spPr>
+          <a:xfrm>
+            <a:off x="286207" y="109728"/>
+            <a:ext cx="646480" cy="950976"/>
+          </a:xfrm>
+          <a:prstGeom prst="rect">
+            <a:avLst/>
+          </a:prstGeom>
+        </p:spPr>
+      </p:pic>
+      <p:sp>
+        <p:nvSpPr>
+          <p:cNvPr id="3" name="TextBox 2"/>
+          <p:cNvSpPr txBox="1"/>
+          <p:nvPr/>
+        </p:nvSpPr>
+        <p:spPr>
+          <a:xfrm>
+            <a:off x="1188720" y="384048"/>
+            <a:ext cx="9814255" cy="548640"/>
+          </a:xfrm>
+          <a:prstGeom prst="rect">
+            <a:avLst/>
+          </a:prstGeom>
+          <a:noFill/>
+        </p:spPr>
+        <p:txBody>
+          <a:bodyPr wrap="square" lIns="0" rIns="0" tIns="0" bIns="0">
+            <a:noAutofit/>
+          </a:bodyPr>
+          <a:lstStyle/>
+          <a:p>
+            <a:pPr algn="ctr"/>
+            <a:r>
+              <a:rPr sz="2400" b="1" i="0" u="sng">
+                <a:solidFill>
+                  <a:srgbClr val="000000"/>
+                </a:solidFill>
+                <a:latin typeface="Times New Roman"/>
+              </a:rPr>
+              <a:t>Work Plan</a:t>
+            </a:r>
+          </a:p>
+        </p:txBody>
+      </p:sp>
+      <p:sp>
+        <p:nvSpPr>
+          <p:cNvPr id="4" name="TextBox 3"/>
+          <p:cNvSpPr txBox="1"/>
+          <p:nvPr/>
+        </p:nvSpPr>
+        <p:spPr>
+          <a:xfrm>
+            <a:off x="929944" y="6355080"/>
+            <a:ext cx="2286000" cy="292608"/>
+          </a:xfrm>
+          <a:prstGeom prst="rect">
+            <a:avLst/>
+          </a:prstGeom>
+          <a:noFill/>
+        </p:spPr>
+        <p:txBody>
+          <a:bodyPr wrap="square" lIns="0" rIns="0" tIns="0" bIns="0">
+            <a:noAutofit/>
+          </a:bodyPr>
+          <a:lstStyle/>
+          <a:p>
+            <a:r>
+              <a:rPr sz="1200" b="0" i="0" u="none">
+                <a:solidFill>
+                  <a:srgbClr val="898989"/>
+                </a:solidFill>
+                <a:latin typeface="Calibri"/>
+              </a:rPr>
+              <a:t>27-08-2026</a:t>
+            </a:r>
+          </a:p>
+        </p:txBody>
+      </p:sp>
+      <p:sp>
+        <p:nvSpPr>
+          <p:cNvPr id="5" name="TextBox 4"/>
+          <p:cNvSpPr txBox="1"/>
+          <p:nvPr/>
+        </p:nvSpPr>
+        <p:spPr>
+          <a:xfrm>
+            <a:off x="3931920" y="6355080"/>
+            <a:ext cx="4297680" cy="292608"/>
+          </a:xfrm>
+          <a:prstGeom prst="rect">
+            <a:avLst/>
+          </a:prstGeom>
+          <a:noFill/>
+        </p:spPr>
+        <p:txBody>
+          <a:bodyPr wrap="square" lIns="0" rIns="0" tIns="0" bIns="0">
+            <a:noAutofit/>
+          </a:bodyPr>
+          <a:lstStyle/>
+          <a:p>
+            <a:pPr algn="ctr"/>
+            <a:r>
+              <a:rPr sz="1200" b="0" i="0" u="none">
+                <a:solidFill>
+                  <a:srgbClr val="898989"/>
+                </a:solidFill>
+                <a:latin typeface="Calibri"/>
+              </a:rPr>
+              <a:t>First Review-2026-27</a:t>
+            </a:r>
+          </a:p>
+        </p:txBody>
+      </p:sp>
+      <p:sp>
+        <p:nvSpPr>
+          <p:cNvPr id="6" name="TextBox 5"/>
+          <p:cNvSpPr txBox="1"/>
+          <p:nvPr/>
+        </p:nvSpPr>
+        <p:spPr>
+          <a:xfrm>
+            <a:off x="10058400" y="6355080"/>
+            <a:ext cx="1204264" cy="292608"/>
+          </a:xfrm>
+          <a:prstGeom prst="rect">
+            <a:avLst/>
+          </a:prstGeom>
+          <a:noFill/>
+        </p:spPr>
+        <p:txBody>
+          <a:bodyPr wrap="square" lIns="0" rIns="0" tIns="0" bIns="0">
+            <a:noAutofit/>
+          </a:bodyPr>
+          <a:lstStyle/>
+          <a:p>
+            <a:pPr algn="r"/>
+            <a:r>
+              <a:rPr sz="1200" b="0" i="0" u="none">
+                <a:solidFill>
+                  <a:srgbClr val="898989"/>
+                </a:solidFill>
+                <a:latin typeface="Calibri"/>
+              </a:rPr>
+              <a:t>17</a:t>
+            </a:r>
+          </a:p>
+        </p:txBody>
+      </p:sp>
+      <p:pic>
+        <p:nvPicPr>
+          <p:cNvPr id="7" name="Picture 6" descr="10_gantt.png"/>
+          <p:cNvPicPr>
+            <a:picLocks noChangeAspect="1"/>
+          </p:cNvPicPr>
+          <p:nvPr/>
+        </p:nvPicPr>
+        <p:blipFill>
+          <a:blip r:embed="rId3"/>
+          <a:stretch>
+            <a:fillRect/>
+          </a:stretch>
+        </p:blipFill>
+        <p:spPr>
+          <a:xfrm>
+            <a:off x="772578" y="1298448"/>
+            <a:ext cx="10643795" cy="4828032"/>
+          </a:xfrm>
+          <a:prstGeom prst="rect">
+            <a:avLst/>
+          </a:prstGeom>
+        </p:spPr>
+      </p:pic>
+    </p:spTree>
+  </p:cSld>
+  <p:clrMapOvr>
+    <a:masterClrMapping/>
+  </p:clrMapOvr>
+</p:sld>
+</file>
+
 <file path=ppt/slides/slide18.xml><?xml version="1.0" encoding="utf-8"?>
 <p:sld xmlns:a="http://schemas.openxmlformats.org/drawingml/2006/main" xmlns:p="http://schemas.openxmlformats.org/presentationml/2006/main" xmlns:r="http://schemas.openxmlformats.org/officeDocument/2006/relationships">
   <p:cSld>
@@ -9771,7 +9527,7 @@
                 </a:solidFill>
                 <a:latin typeface="Times New Roman"/>
               </a:rPr>
-              <a:t>Work Plan</a:t>
+              <a:t>Expected Outcomes</a:t>
             </a:r>
           </a:p>
         </p:txBody>
@@ -9880,30 +9636,113 @@
           </a:p>
         </p:txBody>
       </p:sp>
-      <p:pic>
-        <p:nvPicPr>
-          <p:cNvPr id="7" name="Picture 6" descr="10_gantt.png"/>
-          <p:cNvPicPr>
-            <a:picLocks noChangeAspect="1"/>
-          </p:cNvPicPr>
+      <p:sp>
+        <p:nvSpPr>
+          <p:cNvPr id="7" name="TextBox 6"/>
+          <p:cNvSpPr txBox="1"/>
           <p:nvPr/>
-        </p:nvPicPr>
-        <p:blipFill>
-          <a:blip r:embed="rId3"/>
-          <a:stretch>
-            <a:fillRect/>
-          </a:stretch>
-        </p:blipFill>
-        <p:spPr>
-          <a:xfrm>
-            <a:off x="772578" y="1298448"/>
-            <a:ext cx="10643795" cy="4828032"/>
-          </a:xfrm>
-          <a:prstGeom prst="rect">
-            <a:avLst/>
-          </a:prstGeom>
-        </p:spPr>
-      </p:pic>
+        </p:nvSpPr>
+        <p:spPr>
+          <a:xfrm>
+            <a:off x="1168603" y="1389888"/>
+            <a:ext cx="10195560" cy="4754879"/>
+          </a:xfrm>
+          <a:prstGeom prst="rect">
+            <a:avLst/>
+          </a:prstGeom>
+          <a:noFill/>
+        </p:spPr>
+        <p:txBody>
+          <a:bodyPr wrap="square" lIns="0" rIns="0" tIns="0" bIns="0">
+            <a:noAutofit/>
+          </a:bodyPr>
+          <a:lstStyle/>
+          <a:p>
+            <a:pPr marL="283464" indent="-283464">
+              <a:lnSpc>
+                <a:spcPct val="110000"/>
+              </a:lnSpc>
+              <a:spcAft>
+                <a:spcPts val="2600"/>
+              </a:spcAft>
+              <a:buFont typeface="Arial"/>
+              <a:buChar char="•"/>
+            </a:pPr>
+            <a:r>
+              <a:rPr sz="1800" b="0" i="0" u="none">
+                <a:solidFill>
+                  <a:srgbClr val="000000"/>
+                </a:solidFill>
+                <a:latin typeface="Times New Roman"/>
+              </a:rPr>
+              <a:t>A working 4S BMS that cuts off on temperature rate, demonstrated on the bench</a:t>
+            </a:r>
+          </a:p>
+          <a:p>
+            <a:pPr marL="283464" indent="-283464">
+              <a:lnSpc>
+                <a:spcPct val="110000"/>
+              </a:lnSpc>
+              <a:spcAft>
+                <a:spcPts val="2600"/>
+              </a:spcAft>
+              <a:buFont typeface="Arial"/>
+              <a:buChar char="•"/>
+            </a:pPr>
+            <a:r>
+              <a:rPr sz="1800" b="0" i="0" u="none">
+                <a:solidFill>
+                  <a:srgbClr val="000000"/>
+                </a:solidFill>
+                <a:latin typeface="Times New Roman"/>
+              </a:rPr>
+              <a:t>Measured proof that the rate trip fires earlier than a fixed 60 °C limit</a:t>
+            </a:r>
+          </a:p>
+          <a:p>
+            <a:pPr marL="283464" indent="-283464">
+              <a:lnSpc>
+                <a:spcPct val="110000"/>
+              </a:lnSpc>
+              <a:spcAft>
+                <a:spcPts val="2600"/>
+              </a:spcAft>
+              <a:buFont typeface="Arial"/>
+              <a:buChar char="•"/>
+            </a:pPr>
+            <a:r>
+              <a:rPr sz="1800" b="0" i="0" u="none">
+                <a:solidFill>
+                  <a:srgbClr val="000000"/>
+                </a:solidFill>
+                <a:latin typeface="Times New Roman"/>
+              </a:rPr>
+              <a:t>A live dashboard showing voltage, current, temperature and rate for every cell</a:t>
+            </a:r>
+          </a:p>
+          <a:p>
+            <a:pPr marL="283464" indent="-283464">
+              <a:lnSpc>
+                <a:spcPct val="110000"/>
+              </a:lnSpc>
+              <a:spcAft>
+                <a:spcPts val="2600"/>
+              </a:spcAft>
+              <a:buFont typeface="Arial"/>
+              <a:buChar char="•"/>
+            </a:pPr>
+            <a:r>
+              <a:rPr sz="1800" b="0" i="0" u="none">
+                <a:solidFill>
+                  <a:srgbClr val="000000"/>
+                </a:solidFill>
+                <a:latin typeface="Times New Roman"/>
+              </a:rPr>
+              <a:t>A design that costs about ₹3,000 and uses only parts available in India</a:t>
+            </a:r>
+          </a:p>
+        </p:txBody>
+      </p:sp>
     </p:spTree>
   </p:cSld>
   <p:clrMapOvr>
@@ -9976,7 +9815,7 @@
                 </a:solidFill>
                 <a:latin typeface="Times New Roman"/>
               </a:rPr>
-              <a:t>Expected Outcomes</a:t>
+              <a:t>References</a:t>
             </a:r>
           </a:p>
         </p:txBody>
@@ -10107,87 +9946,148 @@
           </a:bodyPr>
           <a:lstStyle/>
           <a:p>
-            <a:pPr marL="283464" indent="-283464">
+            <a:pPr marL="384048" indent="-384048">
               <a:lnSpc>
                 <a:spcPct val="110000"/>
               </a:lnSpc>
               <a:spcAft>
-                <a:spcPts val="2600"/>
+                <a:spcPts val="2000"/>
               </a:spcAft>
-              <a:buFont typeface="Arial"/>
-              <a:buChar char="•"/>
+              <a:buNone/>
             </a:pPr>
             <a:r>
-              <a:rPr sz="1800" b="0" i="0" u="none">
+              <a:rPr sz="1400" b="0" i="0" u="none">
                 <a:solidFill>
                   <a:srgbClr val="000000"/>
                 </a:solidFill>
                 <a:latin typeface="Times New Roman"/>
               </a:rPr>
-              <a:t>A working 4S BMS that cuts off on temperature rate, demonstrated on the bench</a:t>
-            </a:r>
-          </a:p>
-          <a:p>
-            <a:pPr marL="283464" indent="-283464">
+              <a:t>[1]  </a:t>
+            </a:r>
+            <a:r>
+              <a:rPr sz="1400" b="0" i="0" u="none">
+                <a:solidFill>
+                  <a:srgbClr val="000000"/>
+                </a:solidFill>
+                <a:latin typeface="Times New Roman"/>
+              </a:rPr>
+              <a:t>X. Feng, M. Ouyang, X. Liu, L. Lu, Y. Xia and X. He, “Thermal runaway mechanism of lithium ion battery for electric vehicles: A review,” Energy Storage Materials, vol. 10, pp. 246–267, 2018.</a:t>
+            </a:r>
+          </a:p>
+          <a:p>
+            <a:pPr marL="384048" indent="-384048">
               <a:lnSpc>
                 <a:spcPct val="110000"/>
               </a:lnSpc>
               <a:spcAft>
-                <a:spcPts val="2600"/>
+                <a:spcPts val="2000"/>
               </a:spcAft>
-              <a:buFont typeface="Arial"/>
-              <a:buChar char="•"/>
+              <a:buNone/>
             </a:pPr>
             <a:r>
-              <a:rPr sz="1800" b="0" i="0" u="none">
+              <a:rPr sz="1400" b="0" i="0" u="none">
                 <a:solidFill>
                   <a:srgbClr val="000000"/>
                 </a:solidFill>
                 <a:latin typeface="Times New Roman"/>
               </a:rPr>
-              <a:t>Measured proof that the rate trip fires earlier than a fixed 60 °C limit</a:t>
-            </a:r>
-          </a:p>
-          <a:p>
-            <a:pPr marL="283464" indent="-283464">
+              <a:t>[2]  </a:t>
+            </a:r>
+            <a:r>
+              <a:rPr sz="1400" b="0" i="0" u="none">
+                <a:solidFill>
+                  <a:srgbClr val="000000"/>
+                </a:solidFill>
+                <a:latin typeface="Times New Roman"/>
+              </a:rPr>
+              <a:t>X. Zhang, S. Chen, J. Zhu et al., “A critical review of thermal runaway prediction and early-warning methods for lithium-ion batteries,” Energy Material Advances, vol. 4, art. 0008, 2023.</a:t>
+            </a:r>
+          </a:p>
+          <a:p>
+            <a:pPr marL="384048" indent="-384048">
               <a:lnSpc>
                 <a:spcPct val="110000"/>
               </a:lnSpc>
               <a:spcAft>
-                <a:spcPts val="2600"/>
+                <a:spcPts val="2000"/>
               </a:spcAft>
-              <a:buFont typeface="Arial"/>
-              <a:buChar char="•"/>
+              <a:buNone/>
             </a:pPr>
             <a:r>
-              <a:rPr sz="1800" b="0" i="0" u="none">
+              <a:rPr sz="1400" b="0" i="0" u="none">
                 <a:solidFill>
                   <a:srgbClr val="000000"/>
                 </a:solidFill>
                 <a:latin typeface="Times New Roman"/>
               </a:rPr>
-              <a:t>A live dashboard showing voltage, current, temperature and rate for every cell</a:t>
-            </a:r>
-          </a:p>
-          <a:p>
-            <a:pPr marL="283464" indent="-283464">
+              <a:t>[3]  </a:t>
+            </a:r>
+            <a:r>
+              <a:rPr sz="1400" b="0" i="0" u="none">
+                <a:solidFill>
+                  <a:srgbClr val="000000"/>
+                </a:solidFill>
+                <a:latin typeface="Times New Roman"/>
+              </a:rPr>
+              <a:t>Q. Chen, Y. He, N. Fang and G. Yu, “A combined data-driven and model-based algorithm for accurate battery thermal runaway warning,” Sensors, vol. 24, no. 15, art. 4964, 2024.</a:t>
+            </a:r>
+          </a:p>
+          <a:p>
+            <a:pPr marL="384048" indent="-384048">
               <a:lnSpc>
                 <a:spcPct val="110000"/>
               </a:lnSpc>
               <a:spcAft>
-                <a:spcPts val="2600"/>
+                <a:spcPts val="2000"/>
               </a:spcAft>
-              <a:buFont typeface="Arial"/>
-              <a:buChar char="•"/>
+              <a:buNone/>
             </a:pPr>
             <a:r>
-              <a:rPr sz="1800" b="0" i="0" u="none">
+              <a:rPr sz="1400" b="0" i="0" u="none">
                 <a:solidFill>
                   <a:srgbClr val="000000"/>
                 </a:solidFill>
                 <a:latin typeface="Times New Roman"/>
               </a:rPr>
-              <a:t>A design that costs about ₹3,000 and uses only parts available in India</a:t>
+              <a:t>[4]  </a:t>
+            </a:r>
+            <a:r>
+              <a:rPr sz="1400" b="0" i="0" u="none">
+                <a:solidFill>
+                  <a:srgbClr val="000000"/>
+                </a:solidFill>
+                <a:latin typeface="Times New Roman"/>
+              </a:rPr>
+              <a:t>A. K. M. A. Habib, M. K. Hasan, G. F. Issa, D. Singh, S. Islam and T. M. Ghazal, “Lithium-ion battery management system for electric vehicles: Constraints, challenges and recommendations,” Batteries, vol. 9, no. 3, art. 152, 2023.</a:t>
+            </a:r>
+          </a:p>
+          <a:p>
+            <a:pPr marL="384048" indent="-384048">
+              <a:lnSpc>
+                <a:spcPct val="110000"/>
+              </a:lnSpc>
+              <a:spcAft>
+                <a:spcPts val="2000"/>
+              </a:spcAft>
+              <a:buNone/>
+            </a:pPr>
+            <a:r>
+              <a:rPr sz="1400" b="0" i="0" u="none">
+                <a:solidFill>
+                  <a:srgbClr val="000000"/>
+                </a:solidFill>
+                <a:latin typeface="Times New Roman"/>
+              </a:rPr>
+              <a:t>[5]  </a:t>
+            </a:r>
+            <a:r>
+              <a:rPr sz="1400" b="0" i="0" u="none">
+                <a:solidFill>
+                  <a:srgbClr val="000000"/>
+                </a:solidFill>
+                <a:latin typeface="Times New Roman"/>
+              </a:rPr>
+              <a:t>IS 16046 (Part 2) : 2018 / IEC 62133-2 : 2017, Secondary cells and batteries containing alkaline or other non-acid electrolytes — Part 2: Lithium systems.</a:t>
             </a:r>
           </a:p>
         </p:txBody>
@@ -10400,7 +10300,7 @@
                 <a:spcPct val="110000"/>
               </a:lnSpc>
               <a:spcAft>
-                <a:spcPts val="1300"/>
+                <a:spcPts val="2000"/>
               </a:spcAft>
               <a:buFont typeface="Arial"/>
               <a:buChar char="•"/>
@@ -10412,7 +10312,7 @@
                 </a:solidFill>
                 <a:latin typeface="Times New Roman"/>
               </a:rPr>
-              <a:t>Recap of the zeroth review</a:t>
+              <a:t>Problem statement and objectives</a:t>
             </a:r>
           </a:p>
           <a:p>
@@ -10421,7 +10321,7 @@
                 <a:spcPct val="110000"/>
               </a:lnSpc>
               <a:spcAft>
-                <a:spcPts val="1300"/>
+                <a:spcPts val="2000"/>
               </a:spcAft>
               <a:buFont typeface="Arial"/>
               <a:buChar char="•"/>
@@ -10433,7 +10333,7 @@
                 </a:solidFill>
                 <a:latin typeface="Times New Roman"/>
               </a:rPr>
-              <a:t>Problem statement and objectives</a:t>
+              <a:t>Literature survey</a:t>
             </a:r>
           </a:p>
           <a:p>
@@ -10442,7 +10342,7 @@
                 <a:spcPct val="110000"/>
               </a:lnSpc>
               <a:spcAft>
-                <a:spcPts val="1300"/>
+                <a:spcPts val="2000"/>
               </a:spcAft>
               <a:buFont typeface="Arial"/>
               <a:buChar char="•"/>
@@ -10454,7 +10354,7 @@
                 </a:solidFill>
                 <a:latin typeface="Times New Roman"/>
               </a:rPr>
-              <a:t>Literature survey</a:t>
+              <a:t>Proposed system, hardware and circuits</a:t>
             </a:r>
           </a:p>
           <a:p>
@@ -10463,7 +10363,7 @@
                 <a:spcPct val="110000"/>
               </a:lnSpc>
               <a:spcAft>
-                <a:spcPts val="1300"/>
+                <a:spcPts val="2000"/>
               </a:spcAft>
               <a:buFont typeface="Arial"/>
               <a:buChar char="•"/>
@@ -10475,7 +10375,7 @@
                 </a:solidFill>
                 <a:latin typeface="Times New Roman"/>
               </a:rPr>
-              <a:t>Proposed system, hardware and circuits</a:t>
+              <a:t>Firmware and the predictive algorithm</a:t>
             </a:r>
           </a:p>
           <a:p>
@@ -10484,28 +10384,7 @@
                 <a:spcPct val="110000"/>
               </a:lnSpc>
               <a:spcAft>
-                <a:spcPts val="1300"/>
-              </a:spcAft>
-              <a:buFont typeface="Arial"/>
-              <a:buChar char="•"/>
-            </a:pPr>
-            <a:r>
-              <a:rPr sz="1800" b="0" i="0" u="none">
-                <a:solidFill>
-                  <a:srgbClr val="000000"/>
-                </a:solidFill>
-                <a:latin typeface="Times New Roman"/>
-              </a:rPr>
-              <a:t>Firmware and the predictive algorithm</a:t>
-            </a:r>
-          </a:p>
-          <a:p>
-            <a:pPr marL="283464" indent="-283464">
-              <a:lnSpc>
-                <a:spcPct val="110000"/>
-              </a:lnSpc>
-              <a:spcAft>
-                <a:spcPts val="1300"/>
+                <a:spcPts val="2000"/>
               </a:spcAft>
               <a:buFont typeface="Arial"/>
               <a:buChar char="•"/>
@@ -10572,8 +10451,8 @@
         </p:nvSpPr>
         <p:spPr>
           <a:xfrm>
-            <a:off x="1188720" y="384048"/>
-            <a:ext cx="9814255" cy="548640"/>
+            <a:off x="929944" y="6355080"/>
+            <a:ext cx="2286000" cy="292608"/>
           </a:xfrm>
           <a:prstGeom prst="rect">
             <a:avLst/>
@@ -10586,15 +10465,14 @@
           </a:bodyPr>
           <a:lstStyle/>
           <a:p>
-            <a:pPr algn="ctr"/>
-            <a:r>
-              <a:rPr sz="2400" b="1" i="0" u="sng">
-                <a:solidFill>
-                  <a:srgbClr val="000000"/>
-                </a:solidFill>
-                <a:latin typeface="Times New Roman"/>
-              </a:rPr>
-              <a:t>References</a:t>
+            <a:r>
+              <a:rPr sz="1200" b="0" i="0" u="none">
+                <a:solidFill>
+                  <a:srgbClr val="898989"/>
+                </a:solidFill>
+                <a:latin typeface="Calibri"/>
+              </a:rPr>
+              <a:t>27-08-2026</a:t>
             </a:r>
           </a:p>
         </p:txBody>
@@ -10607,8 +10485,8 @@
         </p:nvSpPr>
         <p:spPr>
           <a:xfrm>
-            <a:off x="929944" y="6355080"/>
-            <a:ext cx="2286000" cy="292608"/>
+            <a:off x="3931920" y="6355080"/>
+            <a:ext cx="4297680" cy="292608"/>
           </a:xfrm>
           <a:prstGeom prst="rect">
             <a:avLst/>
@@ -10621,6 +10499,7 @@
           </a:bodyPr>
           <a:lstStyle/>
           <a:p>
+            <a:pPr algn="ctr"/>
             <a:r>
               <a:rPr sz="1200" b="0" i="0" u="none">
                 <a:solidFill>
@@ -10628,7 +10507,7 @@
                 </a:solidFill>
                 <a:latin typeface="Calibri"/>
               </a:rPr>
-              <a:t>27-08-2026</a:t>
+              <a:t>First Review-2026-27</a:t>
             </a:r>
           </a:p>
         </p:txBody>
@@ -10641,8 +10520,8 @@
         </p:nvSpPr>
         <p:spPr>
           <a:xfrm>
-            <a:off x="3931920" y="6355080"/>
-            <a:ext cx="4297680" cy="292608"/>
+            <a:off x="10058400" y="6355080"/>
+            <a:ext cx="1204264" cy="292608"/>
           </a:xfrm>
           <a:prstGeom prst="rect">
             <a:avLst/>
@@ -10655,7 +10534,7 @@
           </a:bodyPr>
           <a:lstStyle/>
           <a:p>
-            <a:pPr algn="ctr"/>
+            <a:pPr algn="r"/>
             <a:r>
               <a:rPr sz="1200" b="0" i="0" u="none">
                 <a:solidFill>
@@ -10663,356 +10542,7 @@
                 </a:solidFill>
                 <a:latin typeface="Calibri"/>
               </a:rPr>
-              <a:t>First Review-2026-27</a:t>
-            </a:r>
-          </a:p>
-        </p:txBody>
-      </p:sp>
-      <p:sp>
-        <p:nvSpPr>
-          <p:cNvPr id="6" name="TextBox 5"/>
-          <p:cNvSpPr txBox="1"/>
-          <p:nvPr/>
-        </p:nvSpPr>
-        <p:spPr>
-          <a:xfrm>
-            <a:off x="10058400" y="6355080"/>
-            <a:ext cx="1204264" cy="292608"/>
-          </a:xfrm>
-          <a:prstGeom prst="rect">
-            <a:avLst/>
-          </a:prstGeom>
-          <a:noFill/>
-        </p:spPr>
-        <p:txBody>
-          <a:bodyPr wrap="square" lIns="0" rIns="0" tIns="0" bIns="0">
-            <a:noAutofit/>
-          </a:bodyPr>
-          <a:lstStyle/>
-          <a:p>
-            <a:pPr algn="r"/>
-            <a:r>
-              <a:rPr sz="1200" b="0" i="0" u="none">
-                <a:solidFill>
-                  <a:srgbClr val="898989"/>
-                </a:solidFill>
-                <a:latin typeface="Calibri"/>
-              </a:rPr>
               <a:t>20</a:t>
-            </a:r>
-          </a:p>
-        </p:txBody>
-      </p:sp>
-      <p:sp>
-        <p:nvSpPr>
-          <p:cNvPr id="7" name="TextBox 6"/>
-          <p:cNvSpPr txBox="1"/>
-          <p:nvPr/>
-        </p:nvSpPr>
-        <p:spPr>
-          <a:xfrm>
-            <a:off x="1168603" y="1389888"/>
-            <a:ext cx="10195560" cy="4754879"/>
-          </a:xfrm>
-          <a:prstGeom prst="rect">
-            <a:avLst/>
-          </a:prstGeom>
-          <a:noFill/>
-        </p:spPr>
-        <p:txBody>
-          <a:bodyPr wrap="square" lIns="0" rIns="0" tIns="0" bIns="0">
-            <a:noAutofit/>
-          </a:bodyPr>
-          <a:lstStyle/>
-          <a:p>
-            <a:pPr marL="384048" indent="-384048">
-              <a:lnSpc>
-                <a:spcPct val="110000"/>
-              </a:lnSpc>
-              <a:spcAft>
-                <a:spcPts val="2000"/>
-              </a:spcAft>
-              <a:buNone/>
-            </a:pPr>
-            <a:r>
-              <a:rPr sz="1400" b="0" i="0" u="none">
-                <a:solidFill>
-                  <a:srgbClr val="000000"/>
-                </a:solidFill>
-                <a:latin typeface="Times New Roman"/>
-              </a:rPr>
-              <a:t>[1]  </a:t>
-            </a:r>
-            <a:r>
-              <a:rPr sz="1400" b="0" i="0" u="none">
-                <a:solidFill>
-                  <a:srgbClr val="000000"/>
-                </a:solidFill>
-                <a:latin typeface="Times New Roman"/>
-              </a:rPr>
-              <a:t>X. Feng, M. Ouyang, X. Liu, L. Lu, Y. Xia and X. He, “Thermal runaway mechanism of lithium ion battery for electric vehicles: A review,” Energy Storage Materials, vol. 10, pp. 246–267, 2018.</a:t>
-            </a:r>
-          </a:p>
-          <a:p>
-            <a:pPr marL="384048" indent="-384048">
-              <a:lnSpc>
-                <a:spcPct val="110000"/>
-              </a:lnSpc>
-              <a:spcAft>
-                <a:spcPts val="2000"/>
-              </a:spcAft>
-              <a:buNone/>
-            </a:pPr>
-            <a:r>
-              <a:rPr sz="1400" b="0" i="0" u="none">
-                <a:solidFill>
-                  <a:srgbClr val="000000"/>
-                </a:solidFill>
-                <a:latin typeface="Times New Roman"/>
-              </a:rPr>
-              <a:t>[2]  </a:t>
-            </a:r>
-            <a:r>
-              <a:rPr sz="1400" b="0" i="0" u="none">
-                <a:solidFill>
-                  <a:srgbClr val="000000"/>
-                </a:solidFill>
-                <a:latin typeface="Times New Roman"/>
-              </a:rPr>
-              <a:t>X. Zhang, S. Chen, J. Zhu et al., “A critical review of thermal runaway prediction and early-warning methods for lithium-ion batteries,” Energy Material Advances, vol. 4, art. 0008, 2023.</a:t>
-            </a:r>
-          </a:p>
-          <a:p>
-            <a:pPr marL="384048" indent="-384048">
-              <a:lnSpc>
-                <a:spcPct val="110000"/>
-              </a:lnSpc>
-              <a:spcAft>
-                <a:spcPts val="2000"/>
-              </a:spcAft>
-              <a:buNone/>
-            </a:pPr>
-            <a:r>
-              <a:rPr sz="1400" b="0" i="0" u="none">
-                <a:solidFill>
-                  <a:srgbClr val="000000"/>
-                </a:solidFill>
-                <a:latin typeface="Times New Roman"/>
-              </a:rPr>
-              <a:t>[3]  </a:t>
-            </a:r>
-            <a:r>
-              <a:rPr sz="1400" b="0" i="0" u="none">
-                <a:solidFill>
-                  <a:srgbClr val="000000"/>
-                </a:solidFill>
-                <a:latin typeface="Times New Roman"/>
-              </a:rPr>
-              <a:t>Q. Chen, Y. He, N. Fang and G. Yu, “A combined data-driven and model-based algorithm for accurate battery thermal runaway warning,” Sensors, vol. 24, no. 15, art. 4964, 2024.</a:t>
-            </a:r>
-          </a:p>
-          <a:p>
-            <a:pPr marL="384048" indent="-384048">
-              <a:lnSpc>
-                <a:spcPct val="110000"/>
-              </a:lnSpc>
-              <a:spcAft>
-                <a:spcPts val="2000"/>
-              </a:spcAft>
-              <a:buNone/>
-            </a:pPr>
-            <a:r>
-              <a:rPr sz="1400" b="0" i="0" u="none">
-                <a:solidFill>
-                  <a:srgbClr val="000000"/>
-                </a:solidFill>
-                <a:latin typeface="Times New Roman"/>
-              </a:rPr>
-              <a:t>[4]  </a:t>
-            </a:r>
-            <a:r>
-              <a:rPr sz="1400" b="0" i="0" u="none">
-                <a:solidFill>
-                  <a:srgbClr val="000000"/>
-                </a:solidFill>
-                <a:latin typeface="Times New Roman"/>
-              </a:rPr>
-              <a:t>A. K. M. A. Habib, M. K. Hasan, G. F. Issa, D. Singh, S. Islam and T. M. Ghazal, “Lithium-ion battery management system for electric vehicles: Constraints, challenges and recommendations,” Batteries, vol. 9, no. 3, art. 152, 2023.</a:t>
-            </a:r>
-          </a:p>
-          <a:p>
-            <a:pPr marL="384048" indent="-384048">
-              <a:lnSpc>
-                <a:spcPct val="110000"/>
-              </a:lnSpc>
-              <a:spcAft>
-                <a:spcPts val="2000"/>
-              </a:spcAft>
-              <a:buNone/>
-            </a:pPr>
-            <a:r>
-              <a:rPr sz="1400" b="0" i="0" u="none">
-                <a:solidFill>
-                  <a:srgbClr val="000000"/>
-                </a:solidFill>
-                <a:latin typeface="Times New Roman"/>
-              </a:rPr>
-              <a:t>[5]  </a:t>
-            </a:r>
-            <a:r>
-              <a:rPr sz="1400" b="0" i="0" u="none">
-                <a:solidFill>
-                  <a:srgbClr val="000000"/>
-                </a:solidFill>
-                <a:latin typeface="Times New Roman"/>
-              </a:rPr>
-              <a:t>IS 16046 (Part 2) : 2018 / IEC 62133-2 : 2017, Secondary cells and batteries containing alkaline or other non-acid electrolytes — Part 2: Lithium systems.</a:t>
-            </a:r>
-          </a:p>
-        </p:txBody>
-      </p:sp>
-    </p:spTree>
-  </p:cSld>
-  <p:clrMapOvr>
-    <a:masterClrMapping/>
-  </p:clrMapOvr>
-</p:sld>
-</file>
-
-<file path=ppt/slides/slide21.xml><?xml version="1.0" encoding="utf-8"?>
-<p:sld xmlns:a="http://schemas.openxmlformats.org/drawingml/2006/main" xmlns:p="http://schemas.openxmlformats.org/presentationml/2006/main" xmlns:r="http://schemas.openxmlformats.org/officeDocument/2006/relationships">
-  <p:cSld>
-    <p:spTree>
-      <p:nvGrpSpPr>
-        <p:cNvPr id="1" name=""/>
-        <p:cNvGrpSpPr/>
-        <p:nvPr/>
-      </p:nvGrpSpPr>
-      <p:grpSpPr/>
-      <p:pic>
-        <p:nvPicPr>
-          <p:cNvPr id="2" name="Picture 1" descr="logo.png"/>
-          <p:cNvPicPr>
-            <a:picLocks noChangeAspect="1"/>
-          </p:cNvPicPr>
-          <p:nvPr/>
-        </p:nvPicPr>
-        <p:blipFill>
-          <a:blip r:embed="rId2"/>
-          <a:stretch>
-            <a:fillRect/>
-          </a:stretch>
-        </p:blipFill>
-        <p:spPr>
-          <a:xfrm>
-            <a:off x="286207" y="109728"/>
-            <a:ext cx="646480" cy="950976"/>
-          </a:xfrm>
-          <a:prstGeom prst="rect">
-            <a:avLst/>
-          </a:prstGeom>
-        </p:spPr>
-      </p:pic>
-      <p:sp>
-        <p:nvSpPr>
-          <p:cNvPr id="3" name="TextBox 2"/>
-          <p:cNvSpPr txBox="1"/>
-          <p:nvPr/>
-        </p:nvSpPr>
-        <p:spPr>
-          <a:xfrm>
-            <a:off x="929944" y="6355080"/>
-            <a:ext cx="2286000" cy="292608"/>
-          </a:xfrm>
-          <a:prstGeom prst="rect">
-            <a:avLst/>
-          </a:prstGeom>
-          <a:noFill/>
-        </p:spPr>
-        <p:txBody>
-          <a:bodyPr wrap="square" lIns="0" rIns="0" tIns="0" bIns="0">
-            <a:noAutofit/>
-          </a:bodyPr>
-          <a:lstStyle/>
-          <a:p>
-            <a:r>
-              <a:rPr sz="1200" b="0" i="0" u="none">
-                <a:solidFill>
-                  <a:srgbClr val="898989"/>
-                </a:solidFill>
-                <a:latin typeface="Calibri"/>
-              </a:rPr>
-              <a:t>27-08-2026</a:t>
-            </a:r>
-          </a:p>
-        </p:txBody>
-      </p:sp>
-      <p:sp>
-        <p:nvSpPr>
-          <p:cNvPr id="4" name="TextBox 3"/>
-          <p:cNvSpPr txBox="1"/>
-          <p:nvPr/>
-        </p:nvSpPr>
-        <p:spPr>
-          <a:xfrm>
-            <a:off x="3931920" y="6355080"/>
-            <a:ext cx="4297680" cy="292608"/>
-          </a:xfrm>
-          <a:prstGeom prst="rect">
-            <a:avLst/>
-          </a:prstGeom>
-          <a:noFill/>
-        </p:spPr>
-        <p:txBody>
-          <a:bodyPr wrap="square" lIns="0" rIns="0" tIns="0" bIns="0">
-            <a:noAutofit/>
-          </a:bodyPr>
-          <a:lstStyle/>
-          <a:p>
-            <a:pPr algn="ctr"/>
-            <a:r>
-              <a:rPr sz="1200" b="0" i="0" u="none">
-                <a:solidFill>
-                  <a:srgbClr val="898989"/>
-                </a:solidFill>
-                <a:latin typeface="Calibri"/>
-              </a:rPr>
-              <a:t>First Review-2026-27</a:t>
-            </a:r>
-          </a:p>
-        </p:txBody>
-      </p:sp>
-      <p:sp>
-        <p:nvSpPr>
-          <p:cNvPr id="5" name="TextBox 4"/>
-          <p:cNvSpPr txBox="1"/>
-          <p:nvPr/>
-        </p:nvSpPr>
-        <p:spPr>
-          <a:xfrm>
-            <a:off x="10058400" y="6355080"/>
-            <a:ext cx="1204264" cy="292608"/>
-          </a:xfrm>
-          <a:prstGeom prst="rect">
-            <a:avLst/>
-          </a:prstGeom>
-          <a:noFill/>
-        </p:spPr>
-        <p:txBody>
-          <a:bodyPr wrap="square" lIns="0" rIns="0" tIns="0" bIns="0">
-            <a:noAutofit/>
-          </a:bodyPr>
-          <a:lstStyle/>
-          <a:p>
-            <a:pPr algn="r"/>
-            <a:r>
-              <a:rPr sz="1200" b="0" i="0" u="none">
-                <a:solidFill>
-                  <a:srgbClr val="898989"/>
-                </a:solidFill>
-                <a:latin typeface="Calibri"/>
-              </a:rPr>
-              <a:t>21</a:t>
             </a:r>
           </a:p>
         </p:txBody>
@@ -11148,7 +10678,7 @@
                 </a:solidFill>
                 <a:latin typeface="Times New Roman"/>
               </a:rPr>
-              <a:t>Recap of the Zeroth Review</a:t>
+              <a:t>Problem Statement</a:t>
             </a:r>
           </a:p>
         </p:txBody>
@@ -11296,7 +10826,7 @@
                 </a:solidFill>
                 <a:latin typeface="Times New Roman"/>
               </a:rPr>
-              <a:t>The idea was approved: a BMS that acts on how fast a cell heats, not only on how hot it is</a:t>
+              <a:t>A normal small BMS cuts power only when a fixed temperature is crossed, often 60 °C</a:t>
             </a:r>
           </a:p>
           <a:p>
@@ -11317,7 +10847,7 @@
                 </a:solidFill>
                 <a:latin typeface="Times New Roman"/>
               </a:rPr>
-              <a:t>The synopsis and the block diagram were accepted</a:t>
+              <a:t>A cell that is climbing fast at 35 °C is already faulty, but it passes that test</a:t>
             </a:r>
           </a:p>
           <a:p>
@@ -11338,7 +10868,7 @@
                 </a:solidFill>
                 <a:latin typeface="Times New Roman"/>
               </a:rPr>
-              <a:t>My guide signed off, so Phase 1 of the plan is complete</a:t>
+              <a:t>Once a lithium cell starts heating itself, the heat drives more reaction, which makes more heat</a:t>
             </a:r>
           </a:p>
           <a:p>
@@ -11359,7 +10889,7 @@
                 </a:solidFill>
                 <a:latin typeface="Times New Roman"/>
               </a:rPr>
-              <a:t>Since then I have fixed the circuit values and priced every part</a:t>
+              <a:t>A sensor on the outside of a cell always lags what is happening inside it</a:t>
             </a:r>
           </a:p>
           <a:p>
@@ -11380,7 +10910,7 @@
                 </a:solidFill>
                 <a:latin typeface="Times New Roman"/>
               </a:rPr>
-              <a:t>This review covers the detailed design and the firmware plan</a:t>
+              <a:t>So a fixed limit reacts late, and it gives no warning at all beforehand</a:t>
             </a:r>
           </a:p>
         </p:txBody>
@@ -11457,7 +10987,7 @@
                 </a:solidFill>
                 <a:latin typeface="Times New Roman"/>
               </a:rPr>
-              <a:t>Problem Statement</a:t>
+              <a:t>Objectives</a:t>
             </a:r>
           </a:p>
         </p:txBody>
@@ -11605,7 +11135,7 @@
                 </a:solidFill>
                 <a:latin typeface="Times New Roman"/>
               </a:rPr>
-              <a:t>A normal small BMS cuts power only when a fixed temperature is crossed, often 60 °C</a:t>
+              <a:t>Build a working 4S battery management system for 18650 cells</a:t>
             </a:r>
           </a:p>
           <a:p>
@@ -11626,7 +11156,7 @@
                 </a:solidFill>
                 <a:latin typeface="Times New Roman"/>
               </a:rPr>
-              <a:t>A cell that is climbing fast at 35 °C is already faulty, but it passes that test</a:t>
+              <a:t>Measure four cell voltages, the pack current and four cell temperatures</a:t>
             </a:r>
           </a:p>
           <a:p>
@@ -11647,7 +11177,7 @@
                 </a:solidFill>
                 <a:latin typeface="Times New Roman"/>
               </a:rPr>
-              <a:t>Once a lithium cell starts heating itself, the heat drives more reaction, which makes more heat</a:t>
+              <a:t>Trip on the rate at which temperature rises, not only on its value</a:t>
             </a:r>
           </a:p>
           <a:p>
@@ -11668,7 +11198,7 @@
                 </a:solidFill>
                 <a:latin typeface="Times New Roman"/>
               </a:rPr>
-              <a:t>A sensor on the outside of a cell always lags what is happening inside it</a:t>
+              <a:t>Switch charging and discharging separately, so only the unsafe direction stops</a:t>
             </a:r>
           </a:p>
           <a:p>
@@ -11689,7 +11219,7 @@
                 </a:solidFill>
                 <a:latin typeface="Times New Roman"/>
               </a:rPr>
-              <a:t>So a fixed limit reacts late, and it gives no warning at all beforehand</a:t>
+              <a:t>Send every reading over Wi-Fi to a page that opens on a phone or a laptop</a:t>
             </a:r>
           </a:p>
         </p:txBody>
@@ -11766,7 +11296,7 @@
                 </a:solidFill>
                 <a:latin typeface="Times New Roman"/>
               </a:rPr>
-              <a:t>Objectives</a:t>
+              <a:t>Literature Survey</a:t>
             </a:r>
           </a:p>
         </p:txBody>
@@ -11871,315 +11401,6 @@
                 <a:latin typeface="Calibri"/>
               </a:rPr>
               <a:t>5</a:t>
-            </a:r>
-          </a:p>
-        </p:txBody>
-      </p:sp>
-      <p:sp>
-        <p:nvSpPr>
-          <p:cNvPr id="7" name="TextBox 6"/>
-          <p:cNvSpPr txBox="1"/>
-          <p:nvPr/>
-        </p:nvSpPr>
-        <p:spPr>
-          <a:xfrm>
-            <a:off x="1168603" y="1389888"/>
-            <a:ext cx="10195560" cy="4754879"/>
-          </a:xfrm>
-          <a:prstGeom prst="rect">
-            <a:avLst/>
-          </a:prstGeom>
-          <a:noFill/>
-        </p:spPr>
-        <p:txBody>
-          <a:bodyPr wrap="square" lIns="0" rIns="0" tIns="0" bIns="0">
-            <a:noAutofit/>
-          </a:bodyPr>
-          <a:lstStyle/>
-          <a:p>
-            <a:pPr marL="283464" indent="-283464">
-              <a:lnSpc>
-                <a:spcPct val="110000"/>
-              </a:lnSpc>
-              <a:spcAft>
-                <a:spcPts val="2000"/>
-              </a:spcAft>
-              <a:buFont typeface="Arial"/>
-              <a:buChar char="•"/>
-            </a:pPr>
-            <a:r>
-              <a:rPr sz="1800" b="0" i="0" u="none">
-                <a:solidFill>
-                  <a:srgbClr val="000000"/>
-                </a:solidFill>
-                <a:latin typeface="Times New Roman"/>
-              </a:rPr>
-              <a:t>Build a working 4S battery management system for 18650 cells</a:t>
-            </a:r>
-          </a:p>
-          <a:p>
-            <a:pPr marL="283464" indent="-283464">
-              <a:lnSpc>
-                <a:spcPct val="110000"/>
-              </a:lnSpc>
-              <a:spcAft>
-                <a:spcPts val="2000"/>
-              </a:spcAft>
-              <a:buFont typeface="Arial"/>
-              <a:buChar char="•"/>
-            </a:pPr>
-            <a:r>
-              <a:rPr sz="1800" b="0" i="0" u="none">
-                <a:solidFill>
-                  <a:srgbClr val="000000"/>
-                </a:solidFill>
-                <a:latin typeface="Times New Roman"/>
-              </a:rPr>
-              <a:t>Measure four cell voltages, the pack current and four cell temperatures</a:t>
-            </a:r>
-          </a:p>
-          <a:p>
-            <a:pPr marL="283464" indent="-283464">
-              <a:lnSpc>
-                <a:spcPct val="110000"/>
-              </a:lnSpc>
-              <a:spcAft>
-                <a:spcPts val="2000"/>
-              </a:spcAft>
-              <a:buFont typeface="Arial"/>
-              <a:buChar char="•"/>
-            </a:pPr>
-            <a:r>
-              <a:rPr sz="1800" b="0" i="0" u="none">
-                <a:solidFill>
-                  <a:srgbClr val="000000"/>
-                </a:solidFill>
-                <a:latin typeface="Times New Roman"/>
-              </a:rPr>
-              <a:t>Trip on the rate at which temperature rises, not only on its value</a:t>
-            </a:r>
-          </a:p>
-          <a:p>
-            <a:pPr marL="283464" indent="-283464">
-              <a:lnSpc>
-                <a:spcPct val="110000"/>
-              </a:lnSpc>
-              <a:spcAft>
-                <a:spcPts val="2000"/>
-              </a:spcAft>
-              <a:buFont typeface="Arial"/>
-              <a:buChar char="•"/>
-            </a:pPr>
-            <a:r>
-              <a:rPr sz="1800" b="0" i="0" u="none">
-                <a:solidFill>
-                  <a:srgbClr val="000000"/>
-                </a:solidFill>
-                <a:latin typeface="Times New Roman"/>
-              </a:rPr>
-              <a:t>Switch charging and discharging separately, so only the unsafe direction stops</a:t>
-            </a:r>
-          </a:p>
-          <a:p>
-            <a:pPr marL="283464" indent="-283464">
-              <a:lnSpc>
-                <a:spcPct val="110000"/>
-              </a:lnSpc>
-              <a:spcAft>
-                <a:spcPts val="2000"/>
-              </a:spcAft>
-              <a:buFont typeface="Arial"/>
-              <a:buChar char="•"/>
-            </a:pPr>
-            <a:r>
-              <a:rPr sz="1800" b="0" i="0" u="none">
-                <a:solidFill>
-                  <a:srgbClr val="000000"/>
-                </a:solidFill>
-                <a:latin typeface="Times New Roman"/>
-              </a:rPr>
-              <a:t>Send every reading over Wi-Fi to a page that opens on a phone or a laptop</a:t>
-            </a:r>
-          </a:p>
-        </p:txBody>
-      </p:sp>
-    </p:spTree>
-  </p:cSld>
-  <p:clrMapOvr>
-    <a:masterClrMapping/>
-  </p:clrMapOvr>
-</p:sld>
-</file>
-
-<file path=ppt/slides/slide6.xml><?xml version="1.0" encoding="utf-8"?>
-<p:sld xmlns:a="http://schemas.openxmlformats.org/drawingml/2006/main" xmlns:p="http://schemas.openxmlformats.org/presentationml/2006/main" xmlns:r="http://schemas.openxmlformats.org/officeDocument/2006/relationships">
-  <p:cSld>
-    <p:spTree>
-      <p:nvGrpSpPr>
-        <p:cNvPr id="1" name=""/>
-        <p:cNvGrpSpPr/>
-        <p:nvPr/>
-      </p:nvGrpSpPr>
-      <p:grpSpPr/>
-      <p:pic>
-        <p:nvPicPr>
-          <p:cNvPr id="2" name="Picture 1" descr="logo.png"/>
-          <p:cNvPicPr>
-            <a:picLocks noChangeAspect="1"/>
-          </p:cNvPicPr>
-          <p:nvPr/>
-        </p:nvPicPr>
-        <p:blipFill>
-          <a:blip r:embed="rId2"/>
-          <a:stretch>
-            <a:fillRect/>
-          </a:stretch>
-        </p:blipFill>
-        <p:spPr>
-          <a:xfrm>
-            <a:off x="286207" y="109728"/>
-            <a:ext cx="646480" cy="950976"/>
-          </a:xfrm>
-          <a:prstGeom prst="rect">
-            <a:avLst/>
-          </a:prstGeom>
-        </p:spPr>
-      </p:pic>
-      <p:sp>
-        <p:nvSpPr>
-          <p:cNvPr id="3" name="TextBox 2"/>
-          <p:cNvSpPr txBox="1"/>
-          <p:nvPr/>
-        </p:nvSpPr>
-        <p:spPr>
-          <a:xfrm>
-            <a:off x="1188720" y="384048"/>
-            <a:ext cx="9814255" cy="548640"/>
-          </a:xfrm>
-          <a:prstGeom prst="rect">
-            <a:avLst/>
-          </a:prstGeom>
-          <a:noFill/>
-        </p:spPr>
-        <p:txBody>
-          <a:bodyPr wrap="square" lIns="0" rIns="0" tIns="0" bIns="0">
-            <a:noAutofit/>
-          </a:bodyPr>
-          <a:lstStyle/>
-          <a:p>
-            <a:pPr algn="ctr"/>
-            <a:r>
-              <a:rPr sz="2400" b="1" i="0" u="sng">
-                <a:solidFill>
-                  <a:srgbClr val="000000"/>
-                </a:solidFill>
-                <a:latin typeface="Times New Roman"/>
-              </a:rPr>
-              <a:t>Literature Survey</a:t>
-            </a:r>
-          </a:p>
-        </p:txBody>
-      </p:sp>
-      <p:sp>
-        <p:nvSpPr>
-          <p:cNvPr id="4" name="TextBox 3"/>
-          <p:cNvSpPr txBox="1"/>
-          <p:nvPr/>
-        </p:nvSpPr>
-        <p:spPr>
-          <a:xfrm>
-            <a:off x="929944" y="6355080"/>
-            <a:ext cx="2286000" cy="292608"/>
-          </a:xfrm>
-          <a:prstGeom prst="rect">
-            <a:avLst/>
-          </a:prstGeom>
-          <a:noFill/>
-        </p:spPr>
-        <p:txBody>
-          <a:bodyPr wrap="square" lIns="0" rIns="0" tIns="0" bIns="0">
-            <a:noAutofit/>
-          </a:bodyPr>
-          <a:lstStyle/>
-          <a:p>
-            <a:r>
-              <a:rPr sz="1200" b="0" i="0" u="none">
-                <a:solidFill>
-                  <a:srgbClr val="898989"/>
-                </a:solidFill>
-                <a:latin typeface="Calibri"/>
-              </a:rPr>
-              <a:t>27-08-2026</a:t>
-            </a:r>
-          </a:p>
-        </p:txBody>
-      </p:sp>
-      <p:sp>
-        <p:nvSpPr>
-          <p:cNvPr id="5" name="TextBox 4"/>
-          <p:cNvSpPr txBox="1"/>
-          <p:nvPr/>
-        </p:nvSpPr>
-        <p:spPr>
-          <a:xfrm>
-            <a:off x="3931920" y="6355080"/>
-            <a:ext cx="4297680" cy="292608"/>
-          </a:xfrm>
-          <a:prstGeom prst="rect">
-            <a:avLst/>
-          </a:prstGeom>
-          <a:noFill/>
-        </p:spPr>
-        <p:txBody>
-          <a:bodyPr wrap="square" lIns="0" rIns="0" tIns="0" bIns="0">
-            <a:noAutofit/>
-          </a:bodyPr>
-          <a:lstStyle/>
-          <a:p>
-            <a:pPr algn="ctr"/>
-            <a:r>
-              <a:rPr sz="1200" b="0" i="0" u="none">
-                <a:solidFill>
-                  <a:srgbClr val="898989"/>
-                </a:solidFill>
-                <a:latin typeface="Calibri"/>
-              </a:rPr>
-              <a:t>First Review-2026-27</a:t>
-            </a:r>
-          </a:p>
-        </p:txBody>
-      </p:sp>
-      <p:sp>
-        <p:nvSpPr>
-          <p:cNvPr id="6" name="TextBox 5"/>
-          <p:cNvSpPr txBox="1"/>
-          <p:nvPr/>
-        </p:nvSpPr>
-        <p:spPr>
-          <a:xfrm>
-            <a:off x="10058400" y="6355080"/>
-            <a:ext cx="1204264" cy="292608"/>
-          </a:xfrm>
-          <a:prstGeom prst="rect">
-            <a:avLst/>
-          </a:prstGeom>
-          <a:noFill/>
-        </p:spPr>
-        <p:txBody>
-          <a:bodyPr wrap="square" lIns="0" rIns="0" tIns="0" bIns="0">
-            <a:noAutofit/>
-          </a:bodyPr>
-          <a:lstStyle/>
-          <a:p>
-            <a:pPr algn="r"/>
-            <a:r>
-              <a:rPr sz="1200" b="0" i="0" u="none">
-                <a:solidFill>
-                  <a:srgbClr val="898989"/>
-                </a:solidFill>
-                <a:latin typeface="Calibri"/>
-              </a:rPr>
-              <a:t>6</a:t>
             </a:r>
           </a:p>
         </p:txBody>
@@ -12806,6 +12027,270 @@
 </p:sld>
 </file>
 
+<file path=ppt/slides/slide6.xml><?xml version="1.0" encoding="utf-8"?>
+<p:sld xmlns:a="http://schemas.openxmlformats.org/drawingml/2006/main" xmlns:p="http://schemas.openxmlformats.org/presentationml/2006/main" xmlns:r="http://schemas.openxmlformats.org/officeDocument/2006/relationships">
+  <p:cSld>
+    <p:spTree>
+      <p:nvGrpSpPr>
+        <p:cNvPr id="1" name=""/>
+        <p:cNvGrpSpPr/>
+        <p:nvPr/>
+      </p:nvGrpSpPr>
+      <p:grpSpPr/>
+      <p:pic>
+        <p:nvPicPr>
+          <p:cNvPr id="2" name="Picture 1" descr="logo.png"/>
+          <p:cNvPicPr>
+            <a:picLocks noChangeAspect="1"/>
+          </p:cNvPicPr>
+          <p:nvPr/>
+        </p:nvPicPr>
+        <p:blipFill>
+          <a:blip r:embed="rId2"/>
+          <a:stretch>
+            <a:fillRect/>
+          </a:stretch>
+        </p:blipFill>
+        <p:spPr>
+          <a:xfrm>
+            <a:off x="286207" y="109728"/>
+            <a:ext cx="646480" cy="950976"/>
+          </a:xfrm>
+          <a:prstGeom prst="rect">
+            <a:avLst/>
+          </a:prstGeom>
+        </p:spPr>
+      </p:pic>
+      <p:sp>
+        <p:nvSpPr>
+          <p:cNvPr id="3" name="TextBox 2"/>
+          <p:cNvSpPr txBox="1"/>
+          <p:nvPr/>
+        </p:nvSpPr>
+        <p:spPr>
+          <a:xfrm>
+            <a:off x="1188720" y="384048"/>
+            <a:ext cx="9814255" cy="548640"/>
+          </a:xfrm>
+          <a:prstGeom prst="rect">
+            <a:avLst/>
+          </a:prstGeom>
+          <a:noFill/>
+        </p:spPr>
+        <p:txBody>
+          <a:bodyPr wrap="square" lIns="0" rIns="0" tIns="0" bIns="0">
+            <a:noAutofit/>
+          </a:bodyPr>
+          <a:lstStyle/>
+          <a:p>
+            <a:pPr algn="ctr"/>
+            <a:r>
+              <a:rPr sz="2400" b="1" i="0" u="sng">
+                <a:solidFill>
+                  <a:srgbClr val="000000"/>
+                </a:solidFill>
+                <a:latin typeface="Times New Roman"/>
+              </a:rPr>
+              <a:t>Proposed System</a:t>
+            </a:r>
+          </a:p>
+        </p:txBody>
+      </p:sp>
+      <p:sp>
+        <p:nvSpPr>
+          <p:cNvPr id="4" name="TextBox 3"/>
+          <p:cNvSpPr txBox="1"/>
+          <p:nvPr/>
+        </p:nvSpPr>
+        <p:spPr>
+          <a:xfrm>
+            <a:off x="929944" y="6355080"/>
+            <a:ext cx="2286000" cy="292608"/>
+          </a:xfrm>
+          <a:prstGeom prst="rect">
+            <a:avLst/>
+          </a:prstGeom>
+          <a:noFill/>
+        </p:spPr>
+        <p:txBody>
+          <a:bodyPr wrap="square" lIns="0" rIns="0" tIns="0" bIns="0">
+            <a:noAutofit/>
+          </a:bodyPr>
+          <a:lstStyle/>
+          <a:p>
+            <a:r>
+              <a:rPr sz="1200" b="0" i="0" u="none">
+                <a:solidFill>
+                  <a:srgbClr val="898989"/>
+                </a:solidFill>
+                <a:latin typeface="Calibri"/>
+              </a:rPr>
+              <a:t>27-08-2026</a:t>
+            </a:r>
+          </a:p>
+        </p:txBody>
+      </p:sp>
+      <p:sp>
+        <p:nvSpPr>
+          <p:cNvPr id="5" name="TextBox 4"/>
+          <p:cNvSpPr txBox="1"/>
+          <p:nvPr/>
+        </p:nvSpPr>
+        <p:spPr>
+          <a:xfrm>
+            <a:off x="3931920" y="6355080"/>
+            <a:ext cx="4297680" cy="292608"/>
+          </a:xfrm>
+          <a:prstGeom prst="rect">
+            <a:avLst/>
+          </a:prstGeom>
+          <a:noFill/>
+        </p:spPr>
+        <p:txBody>
+          <a:bodyPr wrap="square" lIns="0" rIns="0" tIns="0" bIns="0">
+            <a:noAutofit/>
+          </a:bodyPr>
+          <a:lstStyle/>
+          <a:p>
+            <a:pPr algn="ctr"/>
+            <a:r>
+              <a:rPr sz="1200" b="0" i="0" u="none">
+                <a:solidFill>
+                  <a:srgbClr val="898989"/>
+                </a:solidFill>
+                <a:latin typeface="Calibri"/>
+              </a:rPr>
+              <a:t>First Review-2026-27</a:t>
+            </a:r>
+          </a:p>
+        </p:txBody>
+      </p:sp>
+      <p:sp>
+        <p:nvSpPr>
+          <p:cNvPr id="6" name="TextBox 5"/>
+          <p:cNvSpPr txBox="1"/>
+          <p:nvPr/>
+        </p:nvSpPr>
+        <p:spPr>
+          <a:xfrm>
+            <a:off x="10058400" y="6355080"/>
+            <a:ext cx="1204264" cy="292608"/>
+          </a:xfrm>
+          <a:prstGeom prst="rect">
+            <a:avLst/>
+          </a:prstGeom>
+          <a:noFill/>
+        </p:spPr>
+        <p:txBody>
+          <a:bodyPr wrap="square" lIns="0" rIns="0" tIns="0" bIns="0">
+            <a:noAutofit/>
+          </a:bodyPr>
+          <a:lstStyle/>
+          <a:p>
+            <a:pPr algn="r"/>
+            <a:r>
+              <a:rPr sz="1200" b="0" i="0" u="none">
+                <a:solidFill>
+                  <a:srgbClr val="898989"/>
+                </a:solidFill>
+                <a:latin typeface="Calibri"/>
+              </a:rPr>
+              <a:t>6</a:t>
+            </a:r>
+          </a:p>
+        </p:txBody>
+      </p:sp>
+      <p:sp>
+        <p:nvSpPr>
+          <p:cNvPr id="7" name="TextBox 6"/>
+          <p:cNvSpPr txBox="1"/>
+          <p:nvPr/>
+        </p:nvSpPr>
+        <p:spPr>
+          <a:xfrm>
+            <a:off x="1168603" y="1298448"/>
+            <a:ext cx="10195560" cy="914400"/>
+          </a:xfrm>
+          <a:prstGeom prst="rect">
+            <a:avLst/>
+          </a:prstGeom>
+          <a:noFill/>
+        </p:spPr>
+        <p:txBody>
+          <a:bodyPr wrap="square" lIns="0" rIns="0" tIns="0" bIns="0">
+            <a:noAutofit/>
+          </a:bodyPr>
+          <a:lstStyle/>
+          <a:p>
+            <a:pPr marL="283464" indent="-283464">
+              <a:spcAft>
+                <a:spcPts val="600"/>
+              </a:spcAft>
+              <a:buFont typeface="Arial"/>
+              <a:buChar char="•"/>
+            </a:pPr>
+            <a:r>
+              <a:rPr sz="1700" b="0" i="0" u="none">
+                <a:solidFill>
+                  <a:srgbClr val="000000"/>
+                </a:solidFill>
+                <a:latin typeface="Times New Roman"/>
+              </a:rPr>
+              <a:t>The pack, the sensing, the controller and the protection sit in one loop</a:t>
+            </a:r>
+          </a:p>
+          <a:p>
+            <a:pPr marL="283464" indent="-283464">
+              <a:spcAft>
+                <a:spcPts val="600"/>
+              </a:spcAft>
+              <a:buFont typeface="Arial"/>
+              <a:buChar char="•"/>
+            </a:pPr>
+            <a:r>
+              <a:rPr sz="1700" b="0" i="0" u="none">
+                <a:solidFill>
+                  <a:srgbClr val="000000"/>
+                </a:solidFill>
+                <a:latin typeface="Times New Roman"/>
+              </a:rPr>
+              <a:t>The same readings are used to protect the pack and to feed the dashboard</a:t>
+            </a:r>
+          </a:p>
+        </p:txBody>
+      </p:sp>
+      <p:pic>
+        <p:nvPicPr>
+          <p:cNvPr id="8" name="Picture 7" descr="01_system_block.png"/>
+          <p:cNvPicPr>
+            <a:picLocks noChangeAspect="1"/>
+          </p:cNvPicPr>
+          <p:nvPr/>
+        </p:nvPicPr>
+        <p:blipFill>
+          <a:blip r:embed="rId3"/>
+          <a:stretch>
+            <a:fillRect/>
+          </a:stretch>
+        </p:blipFill>
+        <p:spPr>
+          <a:xfrm>
+            <a:off x="2184195" y="2267712"/>
+            <a:ext cx="7820561" cy="3858768"/>
+          </a:xfrm>
+          <a:prstGeom prst="rect">
+            <a:avLst/>
+          </a:prstGeom>
+        </p:spPr>
+      </p:pic>
+    </p:spTree>
+  </p:cSld>
+  <p:clrMapOvr>
+    <a:masterClrMapping/>
+  </p:clrMapOvr>
+</p:sld>
+</file>
+
 <file path=ppt/slides/slide7.xml><?xml version="1.0" encoding="utf-8"?>
 <p:sld xmlns:a="http://schemas.openxmlformats.org/drawingml/2006/main" xmlns:p="http://schemas.openxmlformats.org/presentationml/2006/main" xmlns:r="http://schemas.openxmlformats.org/officeDocument/2006/relationships">
   <p:cSld>
@@ -12870,7 +12355,7 @@
                 </a:solidFill>
                 <a:latin typeface="Times New Roman"/>
               </a:rPr>
-              <a:t>Proposed System</a:t>
+              <a:t>Hardware Architecture</a:t>
             </a:r>
           </a:p>
         </p:txBody>
@@ -12979,68 +12464,9 @@
           </a:p>
         </p:txBody>
       </p:sp>
-      <p:sp>
-        <p:nvSpPr>
-          <p:cNvPr id="7" name="TextBox 6"/>
-          <p:cNvSpPr txBox="1"/>
-          <p:nvPr/>
-        </p:nvSpPr>
-        <p:spPr>
-          <a:xfrm>
-            <a:off x="1168603" y="1298448"/>
-            <a:ext cx="10195560" cy="914400"/>
-          </a:xfrm>
-          <a:prstGeom prst="rect">
-            <a:avLst/>
-          </a:prstGeom>
-          <a:noFill/>
-        </p:spPr>
-        <p:txBody>
-          <a:bodyPr wrap="square" lIns="0" rIns="0" tIns="0" bIns="0">
-            <a:noAutofit/>
-          </a:bodyPr>
-          <a:lstStyle/>
-          <a:p>
-            <a:pPr marL="283464" indent="-283464">
-              <a:spcAft>
-                <a:spcPts val="600"/>
-              </a:spcAft>
-              <a:buFont typeface="Arial"/>
-              <a:buChar char="•"/>
-            </a:pPr>
-            <a:r>
-              <a:rPr sz="1700" b="0" i="0" u="none">
-                <a:solidFill>
-                  <a:srgbClr val="000000"/>
-                </a:solidFill>
-                <a:latin typeface="Times New Roman"/>
-              </a:rPr>
-              <a:t>The pack, the sensing, the controller and the protection sit in one loop</a:t>
-            </a:r>
-          </a:p>
-          <a:p>
-            <a:pPr marL="283464" indent="-283464">
-              <a:spcAft>
-                <a:spcPts val="600"/>
-              </a:spcAft>
-              <a:buFont typeface="Arial"/>
-              <a:buChar char="•"/>
-            </a:pPr>
-            <a:r>
-              <a:rPr sz="1700" b="0" i="0" u="none">
-                <a:solidFill>
-                  <a:srgbClr val="000000"/>
-                </a:solidFill>
-                <a:latin typeface="Times New Roman"/>
-              </a:rPr>
-              <a:t>The same readings are used to protect the pack and to feed the dashboard</a:t>
-            </a:r>
-          </a:p>
-        </p:txBody>
-      </p:sp>
       <p:pic>
         <p:nvPicPr>
-          <p:cNvPr id="8" name="Picture 7" descr="01_system_block.png"/>
+          <p:cNvPr id="7" name="Picture 6" descr="02_hardware_architecture.png"/>
           <p:cNvPicPr>
             <a:picLocks noChangeAspect="1"/>
           </p:cNvPicPr>
@@ -13054,8 +12480,8 @@
         </p:blipFill>
         <p:spPr>
           <a:xfrm>
-            <a:off x="2184195" y="2267712"/>
-            <a:ext cx="7820561" cy="3858768"/>
+            <a:off x="878477" y="1298448"/>
+            <a:ext cx="10431997" cy="4828032"/>
           </a:xfrm>
           <a:prstGeom prst="rect">
             <a:avLst/>
@@ -13134,7 +12560,7 @@
                 </a:solidFill>
                 <a:latin typeface="Times New Roman"/>
               </a:rPr>
-              <a:t>Hardware Architecture</a:t>
+              <a:t>Power Path — Single Line Diagram</a:t>
             </a:r>
           </a:p>
         </p:txBody>
@@ -13243,9 +12669,68 @@
           </a:p>
         </p:txBody>
       </p:sp>
+      <p:sp>
+        <p:nvSpPr>
+          <p:cNvPr id="7" name="TextBox 6"/>
+          <p:cNvSpPr txBox="1"/>
+          <p:nvPr/>
+        </p:nvSpPr>
+        <p:spPr>
+          <a:xfrm>
+            <a:off x="1168603" y="1298448"/>
+            <a:ext cx="10195560" cy="914400"/>
+          </a:xfrm>
+          <a:prstGeom prst="rect">
+            <a:avLst/>
+          </a:prstGeom>
+          <a:noFill/>
+        </p:spPr>
+        <p:txBody>
+          <a:bodyPr wrap="square" lIns="0" rIns="0" tIns="0" bIns="0">
+            <a:noAutofit/>
+          </a:bodyPr>
+          <a:lstStyle/>
+          <a:p>
+            <a:pPr marL="283464" indent="-283464">
+              <a:spcAft>
+                <a:spcPts val="600"/>
+              </a:spcAft>
+              <a:buFont typeface="Arial"/>
+              <a:buChar char="•"/>
+            </a:pPr>
+            <a:r>
+              <a:rPr sz="1700" b="0" i="0" u="none">
+                <a:solidFill>
+                  <a:srgbClr val="000000"/>
+                </a:solidFill>
+                <a:latin typeface="Times New Roman"/>
+              </a:rPr>
+              <a:t>The 15 A fuse is the backstop if the electronics fail completely</a:t>
+            </a:r>
+          </a:p>
+          <a:p>
+            <a:pPr marL="283464" indent="-283464">
+              <a:spcAft>
+                <a:spcPts val="600"/>
+              </a:spcAft>
+              <a:buFont typeface="Arial"/>
+              <a:buChar char="•"/>
+            </a:pPr>
+            <a:r>
+              <a:rPr sz="1700" b="0" i="0" u="none">
+                <a:solidFill>
+                  <a:srgbClr val="000000"/>
+                </a:solidFill>
+                <a:latin typeface="Times New Roman"/>
+              </a:rPr>
+              <a:t>Both switches sit in the negative return, so both gates drive against ground</a:t>
+            </a:r>
+          </a:p>
+        </p:txBody>
+      </p:sp>
       <p:pic>
         <p:nvPicPr>
-          <p:cNvPr id="7" name="Picture 6" descr="02_hardware_architecture.png"/>
+          <p:cNvPr id="8" name="Picture 7" descr="03_power_path_sld.png"/>
           <p:cNvPicPr>
             <a:picLocks noChangeAspect="1"/>
           </p:cNvPicPr>
@@ -13259,8 +12744,8 @@
         </p:blipFill>
         <p:spPr>
           <a:xfrm>
-            <a:off x="878477" y="1298448"/>
-            <a:ext cx="10431997" cy="4828032"/>
+            <a:off x="1096422" y="2267712"/>
+            <a:ext cx="9996107" cy="3858768"/>
           </a:xfrm>
           <a:prstGeom prst="rect">
             <a:avLst/>
@@ -13339,7 +12824,7 @@
                 </a:solidFill>
                 <a:latin typeface="Times New Roman"/>
               </a:rPr>
-              <a:t>Power Path — Single Line Diagram</a:t>
+              <a:t>Sensing Circuits</a:t>
             </a:r>
           </a:p>
         </p:txBody>
@@ -13448,68 +12933,9 @@
           </a:p>
         </p:txBody>
       </p:sp>
-      <p:sp>
-        <p:nvSpPr>
-          <p:cNvPr id="7" name="TextBox 6"/>
-          <p:cNvSpPr txBox="1"/>
-          <p:nvPr/>
-        </p:nvSpPr>
-        <p:spPr>
-          <a:xfrm>
-            <a:off x="1168603" y="1298448"/>
-            <a:ext cx="10195560" cy="914400"/>
-          </a:xfrm>
-          <a:prstGeom prst="rect">
-            <a:avLst/>
-          </a:prstGeom>
-          <a:noFill/>
-        </p:spPr>
-        <p:txBody>
-          <a:bodyPr wrap="square" lIns="0" rIns="0" tIns="0" bIns="0">
-            <a:noAutofit/>
-          </a:bodyPr>
-          <a:lstStyle/>
-          <a:p>
-            <a:pPr marL="283464" indent="-283464">
-              <a:spcAft>
-                <a:spcPts val="600"/>
-              </a:spcAft>
-              <a:buFont typeface="Arial"/>
-              <a:buChar char="•"/>
-            </a:pPr>
-            <a:r>
-              <a:rPr sz="1700" b="0" i="0" u="none">
-                <a:solidFill>
-                  <a:srgbClr val="000000"/>
-                </a:solidFill>
-                <a:latin typeface="Times New Roman"/>
-              </a:rPr>
-              <a:t>The 15 A fuse is the backstop if the electronics fail completely</a:t>
-            </a:r>
-          </a:p>
-          <a:p>
-            <a:pPr marL="283464" indent="-283464">
-              <a:spcAft>
-                <a:spcPts val="600"/>
-              </a:spcAft>
-              <a:buFont typeface="Arial"/>
-              <a:buChar char="•"/>
-            </a:pPr>
-            <a:r>
-              <a:rPr sz="1700" b="0" i="0" u="none">
-                <a:solidFill>
-                  <a:srgbClr val="000000"/>
-                </a:solidFill>
-                <a:latin typeface="Times New Roman"/>
-              </a:rPr>
-              <a:t>Both switches sit in the negative return, so both gates drive against ground</a:t>
-            </a:r>
-          </a:p>
-        </p:txBody>
-      </p:sp>
       <p:pic>
         <p:nvPicPr>
-          <p:cNvPr id="8" name="Picture 7" descr="03_power_path_sld.png"/>
+          <p:cNvPr id="7" name="Picture 6" descr="04_voltage_sense_schematic.png"/>
           <p:cNvPicPr>
             <a:picLocks noChangeAspect="1"/>
           </p:cNvPicPr>
@@ -13523,14 +12949,167 @@
         </p:blipFill>
         <p:spPr>
           <a:xfrm>
-            <a:off x="1096422" y="2267712"/>
-            <a:ext cx="9996107" cy="3858768"/>
+            <a:off x="658368" y="1769728"/>
+            <a:ext cx="5230368" cy="2815622"/>
           </a:xfrm>
           <a:prstGeom prst="rect">
             <a:avLst/>
           </a:prstGeom>
         </p:spPr>
       </p:pic>
+      <p:sp>
+        <p:nvSpPr>
+          <p:cNvPr id="8" name="TextBox 7"/>
+          <p:cNvSpPr txBox="1"/>
+          <p:nvPr/>
+        </p:nvSpPr>
+        <p:spPr>
+          <a:xfrm>
+            <a:off x="658368" y="1243584"/>
+            <a:ext cx="5230368" cy="310896"/>
+          </a:xfrm>
+          <a:prstGeom prst="rect">
+            <a:avLst/>
+          </a:prstGeom>
+          <a:noFill/>
+        </p:spPr>
+        <p:txBody>
+          <a:bodyPr wrap="square" lIns="0" rIns="0" tIns="0" bIns="0">
+            <a:noAutofit/>
+          </a:bodyPr>
+          <a:lstStyle/>
+          <a:p>
+            <a:pPr algn="ctr"/>
+            <a:r>
+              <a:rPr sz="1600" b="1" i="0" u="none">
+                <a:solidFill>
+                  <a:srgbClr val="000000"/>
+                </a:solidFill>
+                <a:latin typeface="Times New Roman"/>
+              </a:rPr>
+              <a:t>Cell voltage</a:t>
+            </a:r>
+          </a:p>
+        </p:txBody>
+      </p:sp>
+      <p:pic>
+        <p:nvPicPr>
+          <p:cNvPr id="9" name="Picture 8" descr="05_ntc_schematic.png"/>
+          <p:cNvPicPr>
+            <a:picLocks noChangeAspect="1"/>
+          </p:cNvPicPr>
+          <p:nvPr/>
+        </p:nvPicPr>
+        <p:blipFill>
+          <a:blip r:embed="rId4"/>
+          <a:stretch>
+            <a:fillRect/>
+          </a:stretch>
+        </p:blipFill>
+        <p:spPr>
+          <a:xfrm>
+            <a:off x="6300216" y="1970349"/>
+            <a:ext cx="5230368" cy="2414381"/>
+          </a:xfrm>
+          <a:prstGeom prst="rect">
+            <a:avLst/>
+          </a:prstGeom>
+        </p:spPr>
+      </p:pic>
+      <p:sp>
+        <p:nvSpPr>
+          <p:cNvPr id="10" name="TextBox 9"/>
+          <p:cNvSpPr txBox="1"/>
+          <p:nvPr/>
+        </p:nvSpPr>
+        <p:spPr>
+          <a:xfrm>
+            <a:off x="6300216" y="1243584"/>
+            <a:ext cx="5230368" cy="310896"/>
+          </a:xfrm>
+          <a:prstGeom prst="rect">
+            <a:avLst/>
+          </a:prstGeom>
+          <a:noFill/>
+        </p:spPr>
+        <p:txBody>
+          <a:bodyPr wrap="square" lIns="0" rIns="0" tIns="0" bIns="0">
+            <a:noAutofit/>
+          </a:bodyPr>
+          <a:lstStyle/>
+          <a:p>
+            <a:pPr algn="ctr"/>
+            <a:r>
+              <a:rPr sz="1600" b="1" i="0" u="none">
+                <a:solidFill>
+                  <a:srgbClr val="000000"/>
+                </a:solidFill>
+                <a:latin typeface="Times New Roman"/>
+              </a:rPr>
+              <a:t>Cell temperature</a:t>
+            </a:r>
+          </a:p>
+        </p:txBody>
+      </p:sp>
+      <p:sp>
+        <p:nvSpPr>
+          <p:cNvPr id="11" name="TextBox 10"/>
+          <p:cNvSpPr txBox="1"/>
+          <p:nvPr/>
+        </p:nvSpPr>
+        <p:spPr>
+          <a:xfrm>
+            <a:off x="1168603" y="4928616"/>
+            <a:ext cx="10195560" cy="1216152"/>
+          </a:xfrm>
+          <a:prstGeom prst="rect">
+            <a:avLst/>
+          </a:prstGeom>
+          <a:noFill/>
+        </p:spPr>
+        <p:txBody>
+          <a:bodyPr wrap="square" lIns="0" rIns="0" tIns="0" bIns="0">
+            <a:noAutofit/>
+          </a:bodyPr>
+          <a:lstStyle/>
+          <a:p>
+            <a:pPr marL="283464" indent="-283464">
+              <a:spcAft>
+                <a:spcPts val="800"/>
+              </a:spcAft>
+              <a:buFont typeface="Arial"/>
+              <a:buChar char="•"/>
+            </a:pPr>
+            <a:r>
+              <a:rPr sz="1700" b="0" i="0" u="none">
+                <a:solidFill>
+                  <a:srgbClr val="000000"/>
+                </a:solidFill>
+                <a:latin typeface="Times New Roman"/>
+              </a:rPr>
+              <a:t>Divider ratio 0.128 puts a full 16.8 V pack at 2.15 V — about 4.7 mV per count</a:t>
+            </a:r>
+          </a:p>
+          <a:p>
+            <a:pPr marL="283464" indent="-283464">
+              <a:spcAft>
+                <a:spcPts val="800"/>
+              </a:spcAft>
+              <a:buFont typeface="Arial"/>
+              <a:buChar char="•"/>
+            </a:pPr>
+            <a:r>
+              <a:rPr sz="1700" b="0" i="0" u="none">
+                <a:solidFill>
+                  <a:srgbClr val="000000"/>
+                </a:solidFill>
+                <a:latin typeface="Times New Roman"/>
+              </a:rPr>
+              <a:t>Beta equation: 1/T = 1/T₀ + (1/β)·ln(R/R₀), with T₀ = 298.15 K, R₀ = 10 kΩ, β = 3950 K</a:t>
+            </a:r>
+          </a:p>
+        </p:txBody>
+      </p:sp>
     </p:spTree>
   </p:cSld>
   <p:clrMapOvr>

</xml_diff>